<commit_message>
Update survey PPT: full source text, top-bottom layout
</commit_message>
<xml_diff>
--- a/Effective_Teamwork_2_survey.pptx
+++ b/Effective_Teamwork_2_survey.pptx
@@ -3365,7 +3365,7 @@
               </a:spcAft>
             </a:pPr>
             <a:r>
-              <a:rPr sz="3000" b="1" i="0">
+              <a:rPr sz="2800" b="1" i="0">
                 <a:solidFill>
                   <a:srgbClr val="502379"/>
                 </a:solidFill>
@@ -3384,7 +3384,7 @@
         </p:nvSpPr>
         <p:spPr>
           <a:xfrm>
-            <a:off x="502920" y="1051560"/>
+            <a:off x="502920" y="960120"/>
             <a:ext cx="11338560" cy="457200"/>
           </a:xfrm>
           <a:prstGeom prst="rect">
@@ -3407,7 +3407,7 @@
               </a:spcAft>
             </a:pPr>
             <a:r>
-              <a:rPr sz="1400" b="0" i="0">
+              <a:rPr sz="1300" b="0" i="0">
                 <a:solidFill>
                   <a:srgbClr val="666666"/>
                 </a:solidFill>
@@ -3426,130 +3426,8 @@
         </p:nvSpPr>
         <p:spPr>
           <a:xfrm>
-            <a:off x="640080" y="1737360"/>
-            <a:ext cx="10972800" cy="1280160"/>
-          </a:xfrm>
-          <a:prstGeom prst="rect">
-            <a:avLst/>
-          </a:prstGeom>
-          <a:noFill/>
-        </p:spPr>
-        <p:txBody>
-          <a:bodyPr wrap="square" anchor="t">
-            <a:spAutoFit/>
-          </a:bodyPr>
-          <a:lstStyle/>
-          <a:p>
-            <a:pPr algn="l">
-              <a:lnSpc>
-                <a:spcPct val="100000"/>
-              </a:lnSpc>
-              <a:spcAft>
-                <a:spcPts val="1000"/>
-              </a:spcAft>
-            </a:pPr>
-            <a:r>
-              <a:rPr sz="2600" b="1" i="0">
-                <a:solidFill>
-                  <a:srgbClr val="30124E"/>
-                </a:solidFill>
-                <a:latin typeface="Calibri"/>
-              </a:rPr>
-              <a:t>Do you know what role you are best at in a team?</a:t>
-            </a:r>
-          </a:p>
-        </p:txBody>
-      </p:sp>
-      <p:sp>
-        <p:nvSpPr>
-          <p:cNvPr id="6" name="TextBox 5"/>
-          <p:cNvSpPr txBox="1"/>
-          <p:nvPr/>
-        </p:nvSpPr>
-        <p:spPr>
-          <a:xfrm>
-            <a:off x="640080" y="3108960"/>
-            <a:ext cx="10972800" cy="1463040"/>
-          </a:xfrm>
-          <a:prstGeom prst="rect">
-            <a:avLst/>
-          </a:prstGeom>
-          <a:noFill/>
-        </p:spPr>
-        <p:txBody>
-          <a:bodyPr wrap="square" anchor="t">
-            <a:spAutoFit/>
-          </a:bodyPr>
-          <a:lstStyle/>
-          <a:p>
-            <a:pPr algn="l">
-              <a:lnSpc>
-                <a:spcPct val="100000"/>
-              </a:lnSpc>
-              <a:spcAft>
-                <a:spcPts val="1000"/>
-              </a:spcAft>
-            </a:pPr>
-            <a:r>
-              <a:rPr sz="2000" b="0" i="0">
-                <a:solidFill>
-                  <a:srgbClr val="222222"/>
-                </a:solidFill>
-                <a:latin typeface="Calibri"/>
-              </a:rPr>
-              <a:t>Let's find out with a short test.</a:t>
-            </a:r>
-          </a:p>
-          <a:p>
-            <a:pPr algn="l">
-              <a:lnSpc>
-                <a:spcPct val="100000"/>
-              </a:lnSpc>
-              <a:spcAft>
-                <a:spcPts val="1000"/>
-              </a:spcAft>
-            </a:pPr>
-            <a:r>
-              <a:rPr sz="2000" b="0" i="0">
-                <a:solidFill>
-                  <a:srgbClr val="222222"/>
-                </a:solidFill>
-                <a:latin typeface="Calibri"/>
-              </a:rPr>
-              <a:t>Answer four simple questions.</a:t>
-            </a:r>
-          </a:p>
-          <a:p>
-            <a:pPr algn="l">
-              <a:lnSpc>
-                <a:spcPct val="100000"/>
-              </a:lnSpc>
-              <a:spcAft>
-                <a:spcPts val="1000"/>
-              </a:spcAft>
-            </a:pPr>
-            <a:r>
-              <a:rPr sz="2000" b="0" i="0">
-                <a:solidFill>
-                  <a:srgbClr val="222222"/>
-                </a:solidFill>
-                <a:latin typeface="Calibri"/>
-              </a:rPr>
-              <a:t>Remember your four letters as you go.</a:t>
-            </a:r>
-          </a:p>
-        </p:txBody>
-      </p:sp>
-      <p:sp>
-        <p:nvSpPr>
-          <p:cNvPr id="7" name="TextBox 6"/>
-          <p:cNvSpPr txBox="1"/>
-          <p:nvPr/>
-        </p:nvSpPr>
-        <p:spPr>
-          <a:xfrm>
-            <a:off x="640080" y="5303520"/>
-            <a:ext cx="10972800" cy="548640"/>
+            <a:off x="640080" y="1645920"/>
+            <a:ext cx="10972800" cy="1097280"/>
           </a:xfrm>
           <a:prstGeom prst="rect">
             <a:avLst/>
@@ -3571,13 +3449,135 @@
               </a:spcAft>
             </a:pPr>
             <a:r>
-              <a:rPr sz="1500" b="0" i="1">
-                <a:solidFill>
-                  <a:srgbClr val="666666"/>
+              <a:rPr sz="2600" b="1" i="0">
+                <a:solidFill>
+                  <a:srgbClr val="30124E"/>
                 </a:solidFill>
                 <a:latin typeface="Calibri"/>
               </a:rPr>
-              <a:t>You do not need to share anything yet - just remember your letters.</a:t>
+              <a:t>Do you know what role you are best at in a team?</a:t>
+            </a:r>
+          </a:p>
+        </p:txBody>
+      </p:sp>
+      <p:sp>
+        <p:nvSpPr>
+          <p:cNvPr id="6" name="TextBox 5"/>
+          <p:cNvSpPr txBox="1"/>
+          <p:nvPr/>
+        </p:nvSpPr>
+        <p:spPr>
+          <a:xfrm>
+            <a:off x="640080" y="3017520"/>
+            <a:ext cx="10972800" cy="1828800"/>
+          </a:xfrm>
+          <a:prstGeom prst="rect">
+            <a:avLst/>
+          </a:prstGeom>
+          <a:noFill/>
+        </p:spPr>
+        <p:txBody>
+          <a:bodyPr wrap="square" anchor="t">
+            <a:spAutoFit/>
+          </a:bodyPr>
+          <a:lstStyle/>
+          <a:p>
+            <a:pPr algn="l">
+              <a:lnSpc>
+                <a:spcPct val="100000"/>
+              </a:lnSpc>
+              <a:spcAft>
+                <a:spcPts val="1200"/>
+              </a:spcAft>
+            </a:pPr>
+            <a:r>
+              <a:rPr sz="2000" b="0" i="0">
+                <a:solidFill>
+                  <a:srgbClr val="222222"/>
+                </a:solidFill>
+                <a:latin typeface="Calibri"/>
+              </a:rPr>
+              <a:t>Let's find out with a short test.</a:t>
+            </a:r>
+          </a:p>
+          <a:p>
+            <a:pPr algn="l">
+              <a:lnSpc>
+                <a:spcPct val="100000"/>
+              </a:lnSpc>
+              <a:spcAft>
+                <a:spcPts val="1200"/>
+              </a:spcAft>
+            </a:pPr>
+            <a:r>
+              <a:rPr sz="2000" b="0" i="0">
+                <a:solidFill>
+                  <a:srgbClr val="222222"/>
+                </a:solidFill>
+                <a:latin typeface="Calibri"/>
+              </a:rPr>
+              <a:t>Answer four simple questions.</a:t>
+            </a:r>
+          </a:p>
+          <a:p>
+            <a:pPr algn="l">
+              <a:lnSpc>
+                <a:spcPct val="100000"/>
+              </a:lnSpc>
+              <a:spcAft>
+                <a:spcPts val="1200"/>
+              </a:spcAft>
+            </a:pPr>
+            <a:r>
+              <a:rPr sz="2000" b="0" i="0">
+                <a:solidFill>
+                  <a:srgbClr val="222222"/>
+                </a:solidFill>
+                <a:latin typeface="Calibri"/>
+              </a:rPr>
+              <a:t>Remember your four letters as you go.</a:t>
+            </a:r>
+          </a:p>
+        </p:txBody>
+      </p:sp>
+      <p:sp>
+        <p:nvSpPr>
+          <p:cNvPr id="7" name="TextBox 6"/>
+          <p:cNvSpPr txBox="1"/>
+          <p:nvPr/>
+        </p:nvSpPr>
+        <p:spPr>
+          <a:xfrm>
+            <a:off x="640080" y="5212080"/>
+            <a:ext cx="10972800" cy="548640"/>
+          </a:xfrm>
+          <a:prstGeom prst="rect">
+            <a:avLst/>
+          </a:prstGeom>
+          <a:noFill/>
+        </p:spPr>
+        <p:txBody>
+          <a:bodyPr wrap="square" anchor="t">
+            <a:spAutoFit/>
+          </a:bodyPr>
+          <a:lstStyle/>
+          <a:p>
+            <a:pPr algn="l">
+              <a:lnSpc>
+                <a:spcPct val="100000"/>
+              </a:lnSpc>
+              <a:spcAft>
+                <a:spcPts val="600"/>
+              </a:spcAft>
+            </a:pPr>
+            <a:r>
+              <a:rPr sz="1500" b="0" i="1">
+                <a:solidFill>
+                  <a:srgbClr val="666666"/>
+                </a:solidFill>
+                <a:latin typeface="Calibri"/>
+              </a:rPr>
+              <a:t>Do not share anything yet - just remember your letters.</a:t>
             </a:r>
           </a:p>
         </p:txBody>
@@ -3675,7 +3675,7 @@
               </a:spcAft>
             </a:pPr>
             <a:r>
-              <a:rPr sz="3000" b="1" i="0">
+              <a:rPr sz="2800" b="1" i="0">
                 <a:solidFill>
                   <a:srgbClr val="502379"/>
                 </a:solidFill>
@@ -3694,7 +3694,7 @@
         </p:nvSpPr>
         <p:spPr>
           <a:xfrm>
-            <a:off x="502920" y="1051560"/>
+            <a:off x="502920" y="960120"/>
             <a:ext cx="11338560" cy="457200"/>
           </a:xfrm>
           <a:prstGeom prst="rect">
@@ -3717,51 +3717,9 @@
               </a:spcAft>
             </a:pPr>
             <a:r>
-              <a:rPr sz="1400" b="0" i="0">
+              <a:rPr sz="1300" b="0" i="0">
                 <a:solidFill>
                   <a:srgbClr val="666666"/>
-                </a:solidFill>
-                <a:latin typeface="Calibri"/>
-              </a:rPr>
-              <a:t>Remember your letter</a:t>
-            </a:r>
-          </a:p>
-        </p:txBody>
-      </p:sp>
-      <p:sp>
-        <p:nvSpPr>
-          <p:cNvPr id="5" name="TextBox 4"/>
-          <p:cNvSpPr txBox="1"/>
-          <p:nvPr/>
-        </p:nvSpPr>
-        <p:spPr>
-          <a:xfrm>
-            <a:off x="640080" y="1645920"/>
-            <a:ext cx="10972800" cy="914400"/>
-          </a:xfrm>
-          <a:prstGeom prst="rect">
-            <a:avLst/>
-          </a:prstGeom>
-          <a:noFill/>
-        </p:spPr>
-        <p:txBody>
-          <a:bodyPr wrap="square" anchor="t">
-            <a:spAutoFit/>
-          </a:bodyPr>
-          <a:lstStyle/>
-          <a:p>
-            <a:pPr algn="l">
-              <a:lnSpc>
-                <a:spcPct val="100000"/>
-              </a:lnSpc>
-              <a:spcAft>
-                <a:spcPts val="0"/>
-              </a:spcAft>
-            </a:pPr>
-            <a:r>
-              <a:rPr sz="2400" b="1" i="0">
-                <a:solidFill>
-                  <a:srgbClr val="30124E"/>
                 </a:solidFill>
                 <a:latin typeface="Calibri"/>
               </a:rPr>
@@ -3772,14 +3730,14 @@
       </p:sp>
       <p:sp>
         <p:nvSpPr>
-          <p:cNvPr id="6" name="Rectangle 5"/>
+          <p:cNvPr id="5" name="Rectangle 4"/>
           <p:cNvSpPr/>
           <p:nvPr/>
         </p:nvSpPr>
         <p:spPr>
           <a:xfrm>
-            <a:off x="640080" y="2926080"/>
-            <a:ext cx="5303520" cy="2194560"/>
+            <a:off x="640080" y="1554480"/>
+            <a:ext cx="10972800" cy="2286000"/>
           </a:xfrm>
           <a:prstGeom prst="rect">
             <a:avLst/>
@@ -3787,7 +3745,7 @@
           <a:solidFill>
             <a:srgbClr val="F5F0FA"/>
           </a:solidFill>
-          <a:ln w="17780">
+          <a:ln w="15240">
             <a:solidFill>
               <a:srgbClr val="7C3A9E"/>
             </a:solidFill>
@@ -3818,14 +3776,14 @@
       </p:sp>
       <p:sp>
         <p:nvSpPr>
-          <p:cNvPr id="7" name="TextBox 6"/>
+          <p:cNvPr id="6" name="TextBox 5"/>
           <p:cNvSpPr txBox="1"/>
           <p:nvPr/>
         </p:nvSpPr>
         <p:spPr>
           <a:xfrm>
-            <a:off x="868680" y="3108960"/>
-            <a:ext cx="1097280" cy="914400"/>
+            <a:off x="868680" y="1737360"/>
+            <a:ext cx="10515600" cy="2011680"/>
           </a:xfrm>
           <a:prstGeom prst="rect">
             <a:avLst/>
@@ -3840,76 +3798,53 @@
           <a:p>
             <a:pPr algn="l">
               <a:lnSpc>
-                <a:spcPct val="100000"/>
+                <a:spcPct val="115000"/>
               </a:lnSpc>
               <a:spcAft>
-                <a:spcPts val="600"/>
+                <a:spcPts val="400"/>
               </a:spcAft>
             </a:pPr>
             <a:r>
-              <a:rPr sz="4000" b="1" i="0">
+              <a:rPr sz="1600" b="1" i="0">
                 <a:solidFill>
                   <a:srgbClr val="502379"/>
                 </a:solidFill>
                 <a:latin typeface="Calibri"/>
               </a:rPr>
-              <a:t>E</a:t>
-            </a:r>
-          </a:p>
-        </p:txBody>
-      </p:sp>
-      <p:sp>
-        <p:nvSpPr>
-          <p:cNvPr id="8" name="TextBox 7"/>
-          <p:cNvSpPr txBox="1"/>
-          <p:nvPr/>
-        </p:nvSpPr>
-        <p:spPr>
-          <a:xfrm>
-            <a:off x="2103120" y="3200400"/>
-            <a:ext cx="3657600" cy="1828800"/>
-          </a:xfrm>
-          <a:prstGeom prst="rect">
-            <a:avLst/>
-          </a:prstGeom>
-          <a:noFill/>
-        </p:spPr>
-        <p:txBody>
-          <a:bodyPr wrap="square" anchor="t">
-            <a:spAutoFit/>
-          </a:bodyPr>
-          <a:lstStyle/>
+              <a:t>E - Extroverts (</a:t>
+            </a:r>
+          </a:p>
           <a:p>
             <a:pPr algn="l">
               <a:lnSpc>
-                <a:spcPct val="110000"/>
+                <a:spcPct val="115000"/>
               </a:lnSpc>
               <a:spcAft>
-                <a:spcPts val="600"/>
+                <a:spcPts val="400"/>
               </a:spcAft>
             </a:pPr>
             <a:r>
-              <a:rPr sz="1500" b="0" i="0">
+              <a:rPr sz="1600" b="0" i="0">
                 <a:solidFill>
                   <a:srgbClr val="222222"/>
                 </a:solidFill>
                 <a:latin typeface="Calibri"/>
               </a:rPr>
-              <a:t>Extroverts gain energy from being with others and think out loud.</a:t>
-            </a:r>
-          </a:p>
-        </p:txBody>
-      </p:sp>
-      <p:sp>
-        <p:nvSpPr>
-          <p:cNvPr id="9" name="Rectangle 8"/>
+              <a:t>Extroverts are energised by being with others. Often think out loud and share their personal feelings easily.</a:t>
+            </a:r>
+          </a:p>
+        </p:txBody>
+      </p:sp>
+      <p:sp>
+        <p:nvSpPr>
+          <p:cNvPr id="7" name="Rectangle 6"/>
           <p:cNvSpPr/>
           <p:nvPr/>
         </p:nvSpPr>
         <p:spPr>
           <a:xfrm>
-            <a:off x="6263640" y="2926080"/>
-            <a:ext cx="5303520" cy="2194560"/>
+            <a:off x="640080" y="4023360"/>
+            <a:ext cx="10972800" cy="2286000"/>
           </a:xfrm>
           <a:prstGeom prst="rect">
             <a:avLst/>
@@ -3917,7 +3852,7 @@
           <a:solidFill>
             <a:srgbClr val="F5F0FA"/>
           </a:solidFill>
-          <a:ln w="17780">
+          <a:ln w="15240">
             <a:solidFill>
               <a:srgbClr val="7C3A9E"/>
             </a:solidFill>
@@ -3948,14 +3883,14 @@
       </p:sp>
       <p:sp>
         <p:nvSpPr>
-          <p:cNvPr id="10" name="TextBox 9"/>
+          <p:cNvPr id="8" name="TextBox 7"/>
           <p:cNvSpPr txBox="1"/>
           <p:nvPr/>
         </p:nvSpPr>
         <p:spPr>
           <a:xfrm>
-            <a:off x="6492240" y="3108960"/>
-            <a:ext cx="1097280" cy="914400"/>
+            <a:off x="868680" y="4206240"/>
+            <a:ext cx="10515600" cy="2011680"/>
           </a:xfrm>
           <a:prstGeom prst="rect">
             <a:avLst/>
@@ -3970,62 +3905,39 @@
           <a:p>
             <a:pPr algn="l">
               <a:lnSpc>
-                <a:spcPct val="100000"/>
+                <a:spcPct val="115000"/>
               </a:lnSpc>
               <a:spcAft>
-                <a:spcPts val="600"/>
+                <a:spcPts val="400"/>
               </a:spcAft>
             </a:pPr>
             <a:r>
-              <a:rPr sz="4000" b="1" i="0">
+              <a:rPr sz="1600" b="1" i="0">
                 <a:solidFill>
                   <a:srgbClr val="502379"/>
                 </a:solidFill>
                 <a:latin typeface="Calibri"/>
               </a:rPr>
-              <a:t>I</a:t>
-            </a:r>
-          </a:p>
-        </p:txBody>
-      </p:sp>
-      <p:sp>
-        <p:nvSpPr>
-          <p:cNvPr id="11" name="TextBox 10"/>
-          <p:cNvSpPr txBox="1"/>
-          <p:nvPr/>
-        </p:nvSpPr>
-        <p:spPr>
-          <a:xfrm>
-            <a:off x="7726679" y="3200400"/>
-            <a:ext cx="3657600" cy="1828800"/>
-          </a:xfrm>
-          <a:prstGeom prst="rect">
-            <a:avLst/>
-          </a:prstGeom>
-          <a:noFill/>
-        </p:spPr>
-        <p:txBody>
-          <a:bodyPr wrap="square" anchor="t">
-            <a:spAutoFit/>
-          </a:bodyPr>
-          <a:lstStyle/>
+              <a:t>I - Introverts (</a:t>
+            </a:r>
+          </a:p>
           <a:p>
             <a:pPr algn="l">
               <a:lnSpc>
-                <a:spcPct val="110000"/>
+                <a:spcPct val="115000"/>
               </a:lnSpc>
               <a:spcAft>
-                <a:spcPts val="600"/>
+                <a:spcPts val="400"/>
               </a:spcAft>
             </a:pPr>
             <a:r>
-              <a:rPr sz="1500" b="0" i="0">
+              <a:rPr sz="1600" b="0" i="0">
                 <a:solidFill>
                   <a:srgbClr val="222222"/>
                 </a:solidFill>
                 <a:latin typeface="Calibri"/>
               </a:rPr>
-              <a:t>Introverts gain energy from time alone and think quietly.</a:t>
+              <a:t>Introverts are energised by spending time alone. They are inclined to think things through without speaking and are more private about their feelings.</a:t>
             </a:r>
           </a:p>
         </p:txBody>
@@ -4123,7 +4035,7 @@
               </a:spcAft>
             </a:pPr>
             <a:r>
-              <a:rPr sz="3000" b="1" i="0">
+              <a:rPr sz="2800" b="1" i="0">
                 <a:solidFill>
                   <a:srgbClr val="502379"/>
                 </a:solidFill>
@@ -4142,7 +4054,7 @@
         </p:nvSpPr>
         <p:spPr>
           <a:xfrm>
-            <a:off x="502920" y="1051560"/>
+            <a:off x="502920" y="960120"/>
             <a:ext cx="11338560" cy="457200"/>
           </a:xfrm>
           <a:prstGeom prst="rect">
@@ -4165,51 +4077,9 @@
               </a:spcAft>
             </a:pPr>
             <a:r>
-              <a:rPr sz="1400" b="0" i="0">
+              <a:rPr sz="1300" b="0" i="0">
                 <a:solidFill>
                   <a:srgbClr val="666666"/>
-                </a:solidFill>
-                <a:latin typeface="Calibri"/>
-              </a:rPr>
-              <a:t>Remember your letter</a:t>
-            </a:r>
-          </a:p>
-        </p:txBody>
-      </p:sp>
-      <p:sp>
-        <p:nvSpPr>
-          <p:cNvPr id="5" name="TextBox 4"/>
-          <p:cNvSpPr txBox="1"/>
-          <p:nvPr/>
-        </p:nvSpPr>
-        <p:spPr>
-          <a:xfrm>
-            <a:off x="640080" y="1645920"/>
-            <a:ext cx="10972800" cy="914400"/>
-          </a:xfrm>
-          <a:prstGeom prst="rect">
-            <a:avLst/>
-          </a:prstGeom>
-          <a:noFill/>
-        </p:spPr>
-        <p:txBody>
-          <a:bodyPr wrap="square" anchor="t">
-            <a:spAutoFit/>
-          </a:bodyPr>
-          <a:lstStyle/>
-          <a:p>
-            <a:pPr algn="l">
-              <a:lnSpc>
-                <a:spcPct val="100000"/>
-              </a:lnSpc>
-              <a:spcAft>
-                <a:spcPts val="0"/>
-              </a:spcAft>
-            </a:pPr>
-            <a:r>
-              <a:rPr sz="2400" b="1" i="0">
-                <a:solidFill>
-                  <a:srgbClr val="30124E"/>
                 </a:solidFill>
                 <a:latin typeface="Calibri"/>
               </a:rPr>
@@ -4220,14 +4090,14 @@
       </p:sp>
       <p:sp>
         <p:nvSpPr>
-          <p:cNvPr id="6" name="Rectangle 5"/>
+          <p:cNvPr id="5" name="Rectangle 4"/>
           <p:cNvSpPr/>
           <p:nvPr/>
         </p:nvSpPr>
         <p:spPr>
           <a:xfrm>
-            <a:off x="640080" y="2926080"/>
-            <a:ext cx="5303520" cy="2194560"/>
+            <a:off x="640080" y="1554480"/>
+            <a:ext cx="10972800" cy="2286000"/>
           </a:xfrm>
           <a:prstGeom prst="rect">
             <a:avLst/>
@@ -4235,7 +4105,7 @@
           <a:solidFill>
             <a:srgbClr val="F5F0FA"/>
           </a:solidFill>
-          <a:ln w="17780">
+          <a:ln w="15240">
             <a:solidFill>
               <a:srgbClr val="7C3A9E"/>
             </a:solidFill>
@@ -4266,14 +4136,14 @@
       </p:sp>
       <p:sp>
         <p:nvSpPr>
-          <p:cNvPr id="7" name="TextBox 6"/>
+          <p:cNvPr id="6" name="TextBox 5"/>
           <p:cNvSpPr txBox="1"/>
           <p:nvPr/>
         </p:nvSpPr>
         <p:spPr>
           <a:xfrm>
-            <a:off x="868680" y="3108960"/>
-            <a:ext cx="1097280" cy="914400"/>
+            <a:off x="868680" y="1737360"/>
+            <a:ext cx="10515600" cy="2011680"/>
           </a:xfrm>
           <a:prstGeom prst="rect">
             <a:avLst/>
@@ -4288,76 +4158,53 @@
           <a:p>
             <a:pPr algn="l">
               <a:lnSpc>
-                <a:spcPct val="100000"/>
+                <a:spcPct val="115000"/>
               </a:lnSpc>
               <a:spcAft>
-                <a:spcPts val="600"/>
+                <a:spcPts val="400"/>
               </a:spcAft>
             </a:pPr>
             <a:r>
-              <a:rPr sz="4000" b="1" i="0">
+              <a:rPr sz="1600" b="1" i="0">
                 <a:solidFill>
                   <a:srgbClr val="502379"/>
                 </a:solidFill>
                 <a:latin typeface="Calibri"/>
               </a:rPr>
-              <a:t>S</a:t>
-            </a:r>
-          </a:p>
-        </p:txBody>
-      </p:sp>
-      <p:sp>
-        <p:nvSpPr>
-          <p:cNvPr id="8" name="TextBox 7"/>
-          <p:cNvSpPr txBox="1"/>
-          <p:nvPr/>
-        </p:nvSpPr>
-        <p:spPr>
-          <a:xfrm>
-            <a:off x="2103120" y="3200400"/>
-            <a:ext cx="3657600" cy="1828800"/>
-          </a:xfrm>
-          <a:prstGeom prst="rect">
-            <a:avLst/>
-          </a:prstGeom>
-          <a:noFill/>
-        </p:spPr>
-        <p:txBody>
-          <a:bodyPr wrap="square" anchor="t">
-            <a:spAutoFit/>
-          </a:bodyPr>
-          <a:lstStyle/>
+              <a:t>S - Sensing (</a:t>
+            </a:r>
+          </a:p>
           <a:p>
             <a:pPr algn="l">
               <a:lnSpc>
-                <a:spcPct val="110000"/>
+                <a:spcPct val="115000"/>
               </a:lnSpc>
               <a:spcAft>
-                <a:spcPts val="600"/>
+                <a:spcPts val="400"/>
               </a:spcAft>
             </a:pPr>
             <a:r>
-              <a:rPr sz="1500" b="0" i="0">
+              <a:rPr sz="1600" b="0" i="0">
                 <a:solidFill>
                   <a:srgbClr val="222222"/>
                 </a:solidFill>
                 <a:latin typeface="Calibri"/>
               </a:rPr>
-              <a:t>Sensing types trust concrete facts and what is practical.</a:t>
-            </a:r>
-          </a:p>
-        </p:txBody>
-      </p:sp>
-      <p:sp>
-        <p:nvSpPr>
-          <p:cNvPr id="9" name="Rectangle 8"/>
+              <a:t>Sensing types trust what is certain and concrete. They like new ideas only if they are practical. They value realism and common sense and like to use established skills.</a:t>
+            </a:r>
+          </a:p>
+        </p:txBody>
+      </p:sp>
+      <p:sp>
+        <p:nvSpPr>
+          <p:cNvPr id="7" name="Rectangle 6"/>
           <p:cNvSpPr/>
           <p:nvPr/>
         </p:nvSpPr>
         <p:spPr>
           <a:xfrm>
-            <a:off x="6263640" y="2926080"/>
-            <a:ext cx="5303520" cy="2194560"/>
+            <a:off x="640080" y="4023360"/>
+            <a:ext cx="10972800" cy="2286000"/>
           </a:xfrm>
           <a:prstGeom prst="rect">
             <a:avLst/>
@@ -4365,7 +4212,7 @@
           <a:solidFill>
             <a:srgbClr val="F5F0FA"/>
           </a:solidFill>
-          <a:ln w="17780">
+          <a:ln w="15240">
             <a:solidFill>
               <a:srgbClr val="7C3A9E"/>
             </a:solidFill>
@@ -4396,14 +4243,14 @@
       </p:sp>
       <p:sp>
         <p:nvSpPr>
-          <p:cNvPr id="10" name="TextBox 9"/>
+          <p:cNvPr id="8" name="TextBox 7"/>
           <p:cNvSpPr txBox="1"/>
           <p:nvPr/>
         </p:nvSpPr>
         <p:spPr>
           <a:xfrm>
-            <a:off x="6492240" y="3108960"/>
-            <a:ext cx="1097280" cy="914400"/>
+            <a:off x="868680" y="4206240"/>
+            <a:ext cx="10515600" cy="2011680"/>
           </a:xfrm>
           <a:prstGeom prst="rect">
             <a:avLst/>
@@ -4418,62 +4265,39 @@
           <a:p>
             <a:pPr algn="l">
               <a:lnSpc>
-                <a:spcPct val="100000"/>
+                <a:spcPct val="115000"/>
               </a:lnSpc>
               <a:spcAft>
-                <a:spcPts val="600"/>
+                <a:spcPts val="400"/>
               </a:spcAft>
             </a:pPr>
             <a:r>
-              <a:rPr sz="4000" b="1" i="0">
+              <a:rPr sz="1600" b="1" i="0">
                 <a:solidFill>
                   <a:srgbClr val="502379"/>
                 </a:solidFill>
                 <a:latin typeface="Calibri"/>
               </a:rPr>
-              <a:t>N</a:t>
-            </a:r>
-          </a:p>
-        </p:txBody>
-      </p:sp>
-      <p:sp>
-        <p:nvSpPr>
-          <p:cNvPr id="11" name="TextBox 10"/>
-          <p:cNvSpPr txBox="1"/>
-          <p:nvPr/>
-        </p:nvSpPr>
-        <p:spPr>
-          <a:xfrm>
-            <a:off x="7726679" y="3200400"/>
-            <a:ext cx="3657600" cy="1828800"/>
-          </a:xfrm>
-          <a:prstGeom prst="rect">
-            <a:avLst/>
-          </a:prstGeom>
-          <a:noFill/>
-        </p:spPr>
-        <p:txBody>
-          <a:bodyPr wrap="square" anchor="t">
-            <a:spAutoFit/>
-          </a:bodyPr>
-          <a:lstStyle/>
+              <a:t>N - Intuition (</a:t>
+            </a:r>
+          </a:p>
           <a:p>
             <a:pPr algn="l">
               <a:lnSpc>
-                <a:spcPct val="110000"/>
+                <a:spcPct val="115000"/>
               </a:lnSpc>
               <a:spcAft>
-                <a:spcPts val="600"/>
+                <a:spcPts val="400"/>
               </a:spcAft>
             </a:pPr>
             <a:r>
-              <a:rPr sz="1500" b="0" i="0">
+              <a:rPr sz="1600" b="0" i="0">
                 <a:solidFill>
                   <a:srgbClr val="222222"/>
                 </a:solidFill>
                 <a:latin typeface="Calibri"/>
               </a:rPr>
-              <a:t>Intuition types trust instincts and imagination.</a:t>
+              <a:t>Intuition types trust their instincts, inspiration and inference. They like new ideas for their own sake. They value imagination and innovation and like to learn new skills.</a:t>
             </a:r>
           </a:p>
         </p:txBody>
@@ -4571,7 +4395,7 @@
               </a:spcAft>
             </a:pPr>
             <a:r>
-              <a:rPr sz="3000" b="1" i="0">
+              <a:rPr sz="2800" b="1" i="0">
                 <a:solidFill>
                   <a:srgbClr val="502379"/>
                 </a:solidFill>
@@ -4590,7 +4414,7 @@
         </p:nvSpPr>
         <p:spPr>
           <a:xfrm>
-            <a:off x="502920" y="1051560"/>
+            <a:off x="502920" y="960120"/>
             <a:ext cx="11338560" cy="457200"/>
           </a:xfrm>
           <a:prstGeom prst="rect">
@@ -4613,51 +4437,9 @@
               </a:spcAft>
             </a:pPr>
             <a:r>
-              <a:rPr sz="1400" b="0" i="0">
+              <a:rPr sz="1300" b="0" i="0">
                 <a:solidFill>
                   <a:srgbClr val="666666"/>
-                </a:solidFill>
-                <a:latin typeface="Calibri"/>
-              </a:rPr>
-              <a:t>Remember your letter</a:t>
-            </a:r>
-          </a:p>
-        </p:txBody>
-      </p:sp>
-      <p:sp>
-        <p:nvSpPr>
-          <p:cNvPr id="5" name="TextBox 4"/>
-          <p:cNvSpPr txBox="1"/>
-          <p:nvPr/>
-        </p:nvSpPr>
-        <p:spPr>
-          <a:xfrm>
-            <a:off x="640080" y="1645920"/>
-            <a:ext cx="10972800" cy="914400"/>
-          </a:xfrm>
-          <a:prstGeom prst="rect">
-            <a:avLst/>
-          </a:prstGeom>
-          <a:noFill/>
-        </p:spPr>
-        <p:txBody>
-          <a:bodyPr wrap="square" anchor="t">
-            <a:spAutoFit/>
-          </a:bodyPr>
-          <a:lstStyle/>
-          <a:p>
-            <a:pPr algn="l">
-              <a:lnSpc>
-                <a:spcPct val="100000"/>
-              </a:lnSpc>
-              <a:spcAft>
-                <a:spcPts val="0"/>
-              </a:spcAft>
-            </a:pPr>
-            <a:r>
-              <a:rPr sz="2400" b="1" i="0">
-                <a:solidFill>
-                  <a:srgbClr val="30124E"/>
                 </a:solidFill>
                 <a:latin typeface="Calibri"/>
               </a:rPr>
@@ -4668,14 +4450,14 @@
       </p:sp>
       <p:sp>
         <p:nvSpPr>
-          <p:cNvPr id="6" name="Rectangle 5"/>
+          <p:cNvPr id="5" name="Rectangle 4"/>
           <p:cNvSpPr/>
           <p:nvPr/>
         </p:nvSpPr>
         <p:spPr>
           <a:xfrm>
-            <a:off x="640080" y="2926080"/>
-            <a:ext cx="5303520" cy="2194560"/>
+            <a:off x="640080" y="1554480"/>
+            <a:ext cx="10972800" cy="2286000"/>
           </a:xfrm>
           <a:prstGeom prst="rect">
             <a:avLst/>
@@ -4683,7 +4465,7 @@
           <a:solidFill>
             <a:srgbClr val="F5F0FA"/>
           </a:solidFill>
-          <a:ln w="17780">
+          <a:ln w="15240">
             <a:solidFill>
               <a:srgbClr val="7C3A9E"/>
             </a:solidFill>
@@ -4714,14 +4496,14 @@
       </p:sp>
       <p:sp>
         <p:nvSpPr>
-          <p:cNvPr id="7" name="TextBox 6"/>
+          <p:cNvPr id="6" name="TextBox 5"/>
           <p:cNvSpPr txBox="1"/>
           <p:nvPr/>
         </p:nvSpPr>
         <p:spPr>
           <a:xfrm>
-            <a:off x="868680" y="3108960"/>
-            <a:ext cx="1097280" cy="914400"/>
+            <a:off x="868680" y="1737360"/>
+            <a:ext cx="10515600" cy="2011680"/>
           </a:xfrm>
           <a:prstGeom prst="rect">
             <a:avLst/>
@@ -4736,76 +4518,53 @@
           <a:p>
             <a:pPr algn="l">
               <a:lnSpc>
-                <a:spcPct val="100000"/>
+                <a:spcPct val="115000"/>
               </a:lnSpc>
               <a:spcAft>
-                <a:spcPts val="600"/>
+                <a:spcPts val="400"/>
               </a:spcAft>
             </a:pPr>
             <a:r>
-              <a:rPr sz="4000" b="1" i="0">
+              <a:rPr sz="1600" b="1" i="0">
                 <a:solidFill>
                   <a:srgbClr val="502379"/>
                 </a:solidFill>
                 <a:latin typeface="Calibri"/>
               </a:rPr>
-              <a:t>T</a:t>
-            </a:r>
-          </a:p>
-        </p:txBody>
-      </p:sp>
-      <p:sp>
-        <p:nvSpPr>
-          <p:cNvPr id="8" name="TextBox 7"/>
-          <p:cNvSpPr txBox="1"/>
-          <p:nvPr/>
-        </p:nvSpPr>
-        <p:spPr>
-          <a:xfrm>
-            <a:off x="2103120" y="3200400"/>
-            <a:ext cx="3657600" cy="1828800"/>
-          </a:xfrm>
-          <a:prstGeom prst="rect">
-            <a:avLst/>
-          </a:prstGeom>
-          <a:noFill/>
-        </p:spPr>
-        <p:txBody>
-          <a:bodyPr wrap="square" anchor="t">
-            <a:spAutoFit/>
-          </a:bodyPr>
-          <a:lstStyle/>
+              <a:t>T - Thinking (</a:t>
+            </a:r>
+          </a:p>
           <a:p>
             <a:pPr algn="l">
               <a:lnSpc>
-                <a:spcPct val="110000"/>
+                <a:spcPct val="115000"/>
               </a:lnSpc>
               <a:spcAft>
-                <a:spcPts val="600"/>
+                <a:spcPts val="400"/>
               </a:spcAft>
             </a:pPr>
             <a:r>
-              <a:rPr sz="1500" b="0" i="0">
+              <a:rPr sz="1600" b="0" i="0">
                 <a:solidFill>
                   <a:srgbClr val="222222"/>
                 </a:solidFill>
                 <a:latin typeface="Calibri"/>
               </a:rPr>
-              <a:t>Thinking types step back and analyse, valuing truth and logic.</a:t>
-            </a:r>
-          </a:p>
-        </p:txBody>
-      </p:sp>
-      <p:sp>
-        <p:nvSpPr>
-          <p:cNvPr id="9" name="Rectangle 8"/>
+              <a:t>Thinking types step back from problems and analyse them. They believe truth is more important than tact. They have strong motivation to achieve.</a:t>
+            </a:r>
+          </a:p>
+        </p:txBody>
+      </p:sp>
+      <p:sp>
+        <p:nvSpPr>
+          <p:cNvPr id="7" name="Rectangle 6"/>
           <p:cNvSpPr/>
           <p:nvPr/>
         </p:nvSpPr>
         <p:spPr>
           <a:xfrm>
-            <a:off x="6263640" y="2926080"/>
-            <a:ext cx="5303520" cy="2194560"/>
+            <a:off x="640080" y="4023360"/>
+            <a:ext cx="10972800" cy="2286000"/>
           </a:xfrm>
           <a:prstGeom prst="rect">
             <a:avLst/>
@@ -4813,7 +4572,7 @@
           <a:solidFill>
             <a:srgbClr val="F5F0FA"/>
           </a:solidFill>
-          <a:ln w="17780">
+          <a:ln w="15240">
             <a:solidFill>
               <a:srgbClr val="7C3A9E"/>
             </a:solidFill>
@@ -4844,14 +4603,14 @@
       </p:sp>
       <p:sp>
         <p:nvSpPr>
-          <p:cNvPr id="10" name="TextBox 9"/>
+          <p:cNvPr id="8" name="TextBox 7"/>
           <p:cNvSpPr txBox="1"/>
           <p:nvPr/>
         </p:nvSpPr>
         <p:spPr>
           <a:xfrm>
-            <a:off x="6492240" y="3108960"/>
-            <a:ext cx="1097280" cy="914400"/>
+            <a:off x="868680" y="4206240"/>
+            <a:ext cx="10515600" cy="2011680"/>
           </a:xfrm>
           <a:prstGeom prst="rect">
             <a:avLst/>
@@ -4866,62 +4625,39 @@
           <a:p>
             <a:pPr algn="l">
               <a:lnSpc>
-                <a:spcPct val="100000"/>
+                <a:spcPct val="115000"/>
               </a:lnSpc>
               <a:spcAft>
-                <a:spcPts val="600"/>
+                <a:spcPts val="400"/>
               </a:spcAft>
             </a:pPr>
             <a:r>
-              <a:rPr sz="4000" b="1" i="0">
+              <a:rPr sz="1600" b="1" i="0">
                 <a:solidFill>
                   <a:srgbClr val="502379"/>
                 </a:solidFill>
                 <a:latin typeface="Calibri"/>
               </a:rPr>
-              <a:t>F</a:t>
-            </a:r>
-          </a:p>
-        </p:txBody>
-      </p:sp>
-      <p:sp>
-        <p:nvSpPr>
-          <p:cNvPr id="11" name="TextBox 10"/>
-          <p:cNvSpPr txBox="1"/>
-          <p:nvPr/>
-        </p:nvSpPr>
-        <p:spPr>
-          <a:xfrm>
-            <a:off x="7726679" y="3200400"/>
-            <a:ext cx="3657600" cy="1828800"/>
-          </a:xfrm>
-          <a:prstGeom prst="rect">
-            <a:avLst/>
-          </a:prstGeom>
-          <a:noFill/>
-        </p:spPr>
-        <p:txBody>
-          <a:bodyPr wrap="square" anchor="t">
-            <a:spAutoFit/>
-          </a:bodyPr>
-          <a:lstStyle/>
+              <a:t>F - Feeling (</a:t>
+            </a:r>
+          </a:p>
           <a:p>
             <a:pPr algn="l">
               <a:lnSpc>
-                <a:spcPct val="110000"/>
+                <a:spcPct val="115000"/>
               </a:lnSpc>
               <a:spcAft>
-                <a:spcPts val="600"/>
+                <a:spcPts val="400"/>
               </a:spcAft>
             </a:pPr>
             <a:r>
-              <a:rPr sz="1500" b="0" i="0">
+              <a:rPr sz="1600" b="0" i="0">
                 <a:solidFill>
                   <a:srgbClr val="222222"/>
                 </a:solidFill>
                 <a:latin typeface="Calibri"/>
               </a:rPr>
-              <a:t>Feeling types consider the effect on people and value harmony.</a:t>
+              <a:t>Feeling types think hard about the effects of decisions on individuals. They look for compromises and believe feelings are more important in decision making.</a:t>
             </a:r>
           </a:p>
         </p:txBody>
@@ -5019,7 +4755,7 @@
               </a:spcAft>
             </a:pPr>
             <a:r>
-              <a:rPr sz="3000" b="1" i="0">
+              <a:rPr sz="2800" b="1" i="0">
                 <a:solidFill>
                   <a:srgbClr val="502379"/>
                 </a:solidFill>
@@ -5038,7 +4774,7 @@
         </p:nvSpPr>
         <p:spPr>
           <a:xfrm>
-            <a:off x="502920" y="1051560"/>
+            <a:off x="502920" y="960120"/>
             <a:ext cx="11338560" cy="457200"/>
           </a:xfrm>
           <a:prstGeom prst="rect">
@@ -5061,51 +4797,9 @@
               </a:spcAft>
             </a:pPr>
             <a:r>
-              <a:rPr sz="1400" b="0" i="0">
+              <a:rPr sz="1300" b="0" i="0">
                 <a:solidFill>
                   <a:srgbClr val="666666"/>
-                </a:solidFill>
-                <a:latin typeface="Calibri"/>
-              </a:rPr>
-              <a:t>Remember your letter</a:t>
-            </a:r>
-          </a:p>
-        </p:txBody>
-      </p:sp>
-      <p:sp>
-        <p:nvSpPr>
-          <p:cNvPr id="5" name="TextBox 4"/>
-          <p:cNvSpPr txBox="1"/>
-          <p:nvPr/>
-        </p:nvSpPr>
-        <p:spPr>
-          <a:xfrm>
-            <a:off x="640080" y="1645920"/>
-            <a:ext cx="10972800" cy="914400"/>
-          </a:xfrm>
-          <a:prstGeom prst="rect">
-            <a:avLst/>
-          </a:prstGeom>
-          <a:noFill/>
-        </p:spPr>
-        <p:txBody>
-          <a:bodyPr wrap="square" anchor="t">
-            <a:spAutoFit/>
-          </a:bodyPr>
-          <a:lstStyle/>
-          <a:p>
-            <a:pPr algn="l">
-              <a:lnSpc>
-                <a:spcPct val="100000"/>
-              </a:lnSpc>
-              <a:spcAft>
-                <a:spcPts val="0"/>
-              </a:spcAft>
-            </a:pPr>
-            <a:r>
-              <a:rPr sz="2400" b="1" i="0">
-                <a:solidFill>
-                  <a:srgbClr val="30124E"/>
                 </a:solidFill>
                 <a:latin typeface="Calibri"/>
               </a:rPr>
@@ -5116,14 +4810,14 @@
       </p:sp>
       <p:sp>
         <p:nvSpPr>
-          <p:cNvPr id="6" name="Rectangle 5"/>
+          <p:cNvPr id="5" name="Rectangle 4"/>
           <p:cNvSpPr/>
           <p:nvPr/>
         </p:nvSpPr>
         <p:spPr>
           <a:xfrm>
-            <a:off x="640080" y="2926080"/>
-            <a:ext cx="5303520" cy="2194560"/>
+            <a:off x="640080" y="1554480"/>
+            <a:ext cx="10972800" cy="2286000"/>
           </a:xfrm>
           <a:prstGeom prst="rect">
             <a:avLst/>
@@ -5131,7 +4825,7 @@
           <a:solidFill>
             <a:srgbClr val="F5F0FA"/>
           </a:solidFill>
-          <a:ln w="17780">
+          <a:ln w="15240">
             <a:solidFill>
               <a:srgbClr val="7C3A9E"/>
             </a:solidFill>
@@ -5162,14 +4856,14 @@
       </p:sp>
       <p:sp>
         <p:nvSpPr>
-          <p:cNvPr id="7" name="TextBox 6"/>
+          <p:cNvPr id="6" name="TextBox 5"/>
           <p:cNvSpPr txBox="1"/>
           <p:nvPr/>
         </p:nvSpPr>
         <p:spPr>
           <a:xfrm>
-            <a:off x="868680" y="3108960"/>
-            <a:ext cx="1097280" cy="914400"/>
+            <a:off x="868680" y="1737360"/>
+            <a:ext cx="10515600" cy="2011680"/>
           </a:xfrm>
           <a:prstGeom prst="rect">
             <a:avLst/>
@@ -5184,76 +4878,53 @@
           <a:p>
             <a:pPr algn="l">
               <a:lnSpc>
-                <a:spcPct val="100000"/>
+                <a:spcPct val="115000"/>
               </a:lnSpc>
               <a:spcAft>
-                <a:spcPts val="600"/>
+                <a:spcPts val="400"/>
               </a:spcAft>
             </a:pPr>
             <a:r>
-              <a:rPr sz="4000" b="1" i="0">
+              <a:rPr sz="1600" b="1" i="0">
                 <a:solidFill>
                   <a:srgbClr val="502379"/>
                 </a:solidFill>
                 <a:latin typeface="Calibri"/>
               </a:rPr>
-              <a:t>J</a:t>
-            </a:r>
-          </a:p>
-        </p:txBody>
-      </p:sp>
-      <p:sp>
-        <p:nvSpPr>
-          <p:cNvPr id="8" name="TextBox 7"/>
-          <p:cNvSpPr txBox="1"/>
-          <p:nvPr/>
-        </p:nvSpPr>
-        <p:spPr>
-          <a:xfrm>
-            <a:off x="2103120" y="3200400"/>
-            <a:ext cx="3657600" cy="1828800"/>
-          </a:xfrm>
-          <a:prstGeom prst="rect">
-            <a:avLst/>
-          </a:prstGeom>
-          <a:noFill/>
-        </p:spPr>
-        <p:txBody>
-          <a:bodyPr wrap="square" anchor="t">
-            <a:spAutoFit/>
-          </a:bodyPr>
-          <a:lstStyle/>
+              <a:t>J - Judgement (</a:t>
+            </a:r>
+          </a:p>
           <a:p>
             <a:pPr algn="l">
               <a:lnSpc>
-                <a:spcPct val="110000"/>
+                <a:spcPct val="115000"/>
               </a:lnSpc>
               <a:spcAft>
-                <a:spcPts val="600"/>
+                <a:spcPts val="400"/>
               </a:spcAft>
             </a:pPr>
             <a:r>
-              <a:rPr sz="1500" b="0" i="0">
+              <a:rPr sz="1600" b="0" i="0">
                 <a:solidFill>
                   <a:srgbClr val="222222"/>
                 </a:solidFill>
                 <a:latin typeface="Calibri"/>
               </a:rPr>
-              <a:t>Judging types like decisions made and clear plans.</a:t>
-            </a:r>
-          </a:p>
-        </p:txBody>
-      </p:sp>
-      <p:sp>
-        <p:nvSpPr>
-          <p:cNvPr id="9" name="Rectangle 8"/>
+              <a:t>Judgement types are happiest after decisions are made. They set goals and work towards these, and prefer knowing exactly what is involved.</a:t>
+            </a:r>
+          </a:p>
+        </p:txBody>
+      </p:sp>
+      <p:sp>
+        <p:nvSpPr>
+          <p:cNvPr id="7" name="Rectangle 6"/>
           <p:cNvSpPr/>
           <p:nvPr/>
         </p:nvSpPr>
         <p:spPr>
           <a:xfrm>
-            <a:off x="6263640" y="2926080"/>
-            <a:ext cx="5303520" cy="2194560"/>
+            <a:off x="640080" y="4023360"/>
+            <a:ext cx="10972800" cy="2286000"/>
           </a:xfrm>
           <a:prstGeom prst="rect">
             <a:avLst/>
@@ -5261,7 +4932,7 @@
           <a:solidFill>
             <a:srgbClr val="F5F0FA"/>
           </a:solidFill>
-          <a:ln w="17780">
+          <a:ln w="15240">
             <a:solidFill>
               <a:srgbClr val="7C3A9E"/>
             </a:solidFill>
@@ -5292,14 +4963,14 @@
       </p:sp>
       <p:sp>
         <p:nvSpPr>
-          <p:cNvPr id="10" name="TextBox 9"/>
+          <p:cNvPr id="8" name="TextBox 7"/>
           <p:cNvSpPr txBox="1"/>
           <p:nvPr/>
         </p:nvSpPr>
         <p:spPr>
           <a:xfrm>
-            <a:off x="6492240" y="3108960"/>
-            <a:ext cx="1097280" cy="914400"/>
+            <a:off x="868680" y="4206240"/>
+            <a:ext cx="10515600" cy="2011680"/>
           </a:xfrm>
           <a:prstGeom prst="rect">
             <a:avLst/>
@@ -5314,62 +4985,39 @@
           <a:p>
             <a:pPr algn="l">
               <a:lnSpc>
-                <a:spcPct val="100000"/>
+                <a:spcPct val="115000"/>
               </a:lnSpc>
               <a:spcAft>
-                <a:spcPts val="600"/>
+                <a:spcPts val="400"/>
               </a:spcAft>
             </a:pPr>
             <a:r>
-              <a:rPr sz="4000" b="1" i="0">
+              <a:rPr sz="1600" b="1" i="0">
                 <a:solidFill>
                   <a:srgbClr val="502379"/>
                 </a:solidFill>
                 <a:latin typeface="Calibri"/>
               </a:rPr>
-              <a:t>P</a:t>
-            </a:r>
-          </a:p>
-        </p:txBody>
-      </p:sp>
-      <p:sp>
-        <p:nvSpPr>
-          <p:cNvPr id="11" name="TextBox 10"/>
-          <p:cNvSpPr txBox="1"/>
-          <p:nvPr/>
-        </p:nvSpPr>
-        <p:spPr>
-          <a:xfrm>
-            <a:off x="7726679" y="3200400"/>
-            <a:ext cx="3657600" cy="1828800"/>
-          </a:xfrm>
-          <a:prstGeom prst="rect">
-            <a:avLst/>
-          </a:prstGeom>
-          <a:noFill/>
-        </p:spPr>
-        <p:txBody>
-          <a:bodyPr wrap="square" anchor="t">
-            <a:spAutoFit/>
-          </a:bodyPr>
-          <a:lstStyle/>
+              <a:t>P - Perception (</a:t>
+            </a:r>
+          </a:p>
           <a:p>
             <a:pPr algn="l">
               <a:lnSpc>
-                <a:spcPct val="110000"/>
+                <a:spcPct val="115000"/>
               </a:lnSpc>
               <a:spcAft>
-                <a:spcPts val="600"/>
+                <a:spcPts val="400"/>
               </a:spcAft>
             </a:pPr>
             <a:r>
-              <a:rPr sz="1500" b="0" i="0">
+              <a:rPr sz="1600" b="0" i="0">
                 <a:solidFill>
                   <a:srgbClr val="222222"/>
                 </a:solidFill>
                 <a:latin typeface="Calibri"/>
               </a:rPr>
-              <a:t>Perceiving types like to keep options open and adapt.</a:t>
+              <a:t>Perception types prefer to leave options open. They enjoy adapting to new situations and cope well with ambiguity.</a:t>
             </a:r>
           </a:p>
         </p:txBody>
@@ -5467,7 +5115,7 @@
               </a:spcAft>
             </a:pPr>
             <a:r>
-              <a:rPr sz="3000" b="1" i="0">
+              <a:rPr sz="2800" b="1" i="0">
                 <a:solidFill>
                   <a:srgbClr val="502379"/>
                 </a:solidFill>
@@ -5486,7 +5134,7 @@
         </p:nvSpPr>
         <p:spPr>
           <a:xfrm>
-            <a:off x="502920" y="1051560"/>
+            <a:off x="502920" y="960120"/>
             <a:ext cx="11338560" cy="457200"/>
           </a:xfrm>
           <a:prstGeom prst="rect">
@@ -5509,7 +5157,7 @@
               </a:spcAft>
             </a:pPr>
             <a:r>
-              <a:rPr sz="1400" b="0" i="0">
+              <a:rPr sz="1300" b="0" i="0">
                 <a:solidFill>
                   <a:srgbClr val="666666"/>
                 </a:solidFill>
@@ -5529,7 +5177,7 @@
         <p:spPr>
           <a:xfrm>
             <a:off x="640080" y="1828800"/>
-            <a:ext cx="10972800" cy="1097280"/>
+            <a:ext cx="10972800" cy="914400"/>
           </a:xfrm>
           <a:prstGeom prst="rect">
             <a:avLst/>
@@ -5547,7 +5195,7 @@
                 <a:spcPct val="100000"/>
               </a:lnSpc>
               <a:spcAft>
-                <a:spcPts val="800"/>
+                <a:spcPts val="600"/>
               </a:spcAft>
             </a:pPr>
             <a:r>
@@ -5570,7 +5218,7 @@
         </p:nvSpPr>
         <p:spPr>
           <a:xfrm>
-            <a:off x="640080" y="3108960"/>
+            <a:off x="640080" y="2926080"/>
             <a:ext cx="1188720" cy="1188720"/>
           </a:xfrm>
           <a:prstGeom prst="rect">
@@ -5614,7 +5262,7 @@
         </p:nvSpPr>
         <p:spPr>
           <a:xfrm>
-            <a:off x="640080" y="3246120"/>
+            <a:off x="640080" y="3063240"/>
             <a:ext cx="1188720" cy="914400"/>
           </a:xfrm>
           <a:prstGeom prst="rect">
@@ -5656,7 +5304,7 @@
         </p:nvSpPr>
         <p:spPr>
           <a:xfrm>
-            <a:off x="2103120" y="3108960"/>
+            <a:off x="2103120" y="2926080"/>
             <a:ext cx="1188720" cy="1188720"/>
           </a:xfrm>
           <a:prstGeom prst="rect">
@@ -5700,7 +5348,7 @@
         </p:nvSpPr>
         <p:spPr>
           <a:xfrm>
-            <a:off x="2103120" y="3246120"/>
+            <a:off x="2103120" y="3063240"/>
             <a:ext cx="1188720" cy="914400"/>
           </a:xfrm>
           <a:prstGeom prst="rect">
@@ -5742,7 +5390,7 @@
         </p:nvSpPr>
         <p:spPr>
           <a:xfrm>
-            <a:off x="3566160" y="3108960"/>
+            <a:off x="3566160" y="2926080"/>
             <a:ext cx="1188720" cy="1188720"/>
           </a:xfrm>
           <a:prstGeom prst="rect">
@@ -5786,7 +5434,7 @@
         </p:nvSpPr>
         <p:spPr>
           <a:xfrm>
-            <a:off x="3566160" y="3246120"/>
+            <a:off x="3566160" y="3063240"/>
             <a:ext cx="1188720" cy="914400"/>
           </a:xfrm>
           <a:prstGeom prst="rect">
@@ -5828,7 +5476,7 @@
         </p:nvSpPr>
         <p:spPr>
           <a:xfrm>
-            <a:off x="5029200" y="3108960"/>
+            <a:off x="5029200" y="2926080"/>
             <a:ext cx="1188720" cy="1188720"/>
           </a:xfrm>
           <a:prstGeom prst="rect">
@@ -5872,7 +5520,7 @@
         </p:nvSpPr>
         <p:spPr>
           <a:xfrm>
-            <a:off x="5029200" y="3246120"/>
+            <a:off x="5029200" y="3063240"/>
             <a:ext cx="1188720" cy="914400"/>
           </a:xfrm>
           <a:prstGeom prst="rect">
@@ -5914,8 +5562,8 @@
         </p:nvSpPr>
         <p:spPr>
           <a:xfrm>
-            <a:off x="640080" y="4754880"/>
-            <a:ext cx="10972800" cy="1280160"/>
+            <a:off x="640080" y="4572000"/>
+            <a:ext cx="10972800" cy="1463040"/>
           </a:xfrm>
           <a:prstGeom prst="rect">
             <a:avLst/>
@@ -5933,7 +5581,7 @@
                 <a:spcPct val="100000"/>
               </a:lnSpc>
               <a:spcAft>
-                <a:spcPts val="1000"/>
+                <a:spcPts val="1200"/>
               </a:spcAft>
             </a:pPr>
             <a:r>
@@ -5952,7 +5600,7 @@
                 <a:spcPct val="100000"/>
               </a:lnSpc>
               <a:spcAft>
-                <a:spcPts val="1000"/>
+                <a:spcPts val="1200"/>
               </a:spcAft>
             </a:pPr>
             <a:r>

</xml_diff>

<commit_message>
Survey PPT: capitalized option words with red first letter
</commit_message>
<xml_diff>
--- a/Effective_Teamwork_2_survey.pptx
+++ b/Effective_Teamwork_2_survey.pptx
@@ -3783,7 +3783,7 @@
         <p:spPr>
           <a:xfrm>
             <a:off x="868680" y="1737360"/>
-            <a:ext cx="10515600" cy="2011680"/>
+            <a:ext cx="10515600" cy="1920240"/>
           </a:xfrm>
           <a:prstGeom prst="rect">
             <a:avLst/>
@@ -3791,46 +3791,64 @@
           <a:noFill/>
         </p:spPr>
         <p:txBody>
-          <a:bodyPr wrap="square" anchor="t">
+          <a:bodyPr wrap="square">
             <a:spAutoFit/>
           </a:bodyPr>
           <a:lstStyle/>
           <a:p>
-            <a:pPr algn="l">
+            <a:pPr>
+              <a:lnSpc>
+                <a:spcPct val="110000"/>
+              </a:lnSpc>
+              <a:spcAft>
+                <a:spcPts val="200"/>
+              </a:spcAft>
+            </a:pPr>
+            <a:r>
+              <a:rPr sz="1800" b="1">
+                <a:solidFill>
+                  <a:srgbClr val="E74C3C"/>
+                </a:solidFill>
+                <a:latin typeface="Calibri"/>
+              </a:rPr>
+              <a:t>E</a:t>
+            </a:r>
+            <a:r>
+              <a:rPr sz="1800" b="1">
+                <a:solidFill>
+                  <a:srgbClr val="502379"/>
+                </a:solidFill>
+                <a:latin typeface="Calibri"/>
+              </a:rPr>
+              <a:t>XTROVERTS</a:t>
+            </a:r>
+          </a:p>
+          <a:p>
+            <a:pPr>
               <a:lnSpc>
                 <a:spcPct val="115000"/>
               </a:lnSpc>
               <a:spcAft>
-                <a:spcPts val="400"/>
+                <a:spcPts val="0"/>
               </a:spcAft>
             </a:pPr>
             <a:r>
-              <a:rPr sz="1600" b="1" i="0">
-                <a:solidFill>
-                  <a:srgbClr val="502379"/>
+              <a:rPr sz="1500" b="0">
+                <a:solidFill>
+                  <a:srgbClr val="E74C3C"/>
                 </a:solidFill>
                 <a:latin typeface="Calibri"/>
               </a:rPr>
-              <a:t>E - Extroverts (</a:t>
-            </a:r>
-          </a:p>
-          <a:p>
-            <a:pPr algn="l">
-              <a:lnSpc>
-                <a:spcPct val="115000"/>
-              </a:lnSpc>
-              <a:spcAft>
-                <a:spcPts val="400"/>
-              </a:spcAft>
-            </a:pPr>
-            <a:r>
-              <a:rPr sz="1600" b="0" i="0">
+              <a:t>E</a:t>
+            </a:r>
+            <a:r>
+              <a:rPr sz="1500" b="0">
                 <a:solidFill>
                   <a:srgbClr val="222222"/>
                 </a:solidFill>
                 <a:latin typeface="Calibri"/>
               </a:rPr>
-              <a:t>Extroverts are energised by being with others. Often think out loud and share their personal feelings easily.</a:t>
+              <a:t>xtroverts are energised by being with others. Often think out loud and share their personal feelings easily.</a:t>
             </a:r>
           </a:p>
         </p:txBody>
@@ -3890,7 +3908,7 @@
         <p:spPr>
           <a:xfrm>
             <a:off x="868680" y="4206240"/>
-            <a:ext cx="10515600" cy="2011680"/>
+            <a:ext cx="10515600" cy="1920240"/>
           </a:xfrm>
           <a:prstGeom prst="rect">
             <a:avLst/>
@@ -3898,46 +3916,64 @@
           <a:noFill/>
         </p:spPr>
         <p:txBody>
-          <a:bodyPr wrap="square" anchor="t">
+          <a:bodyPr wrap="square">
             <a:spAutoFit/>
           </a:bodyPr>
           <a:lstStyle/>
           <a:p>
-            <a:pPr algn="l">
+            <a:pPr>
+              <a:lnSpc>
+                <a:spcPct val="110000"/>
+              </a:lnSpc>
+              <a:spcAft>
+                <a:spcPts val="200"/>
+              </a:spcAft>
+            </a:pPr>
+            <a:r>
+              <a:rPr sz="1800" b="1">
+                <a:solidFill>
+                  <a:srgbClr val="E74C3C"/>
+                </a:solidFill>
+                <a:latin typeface="Calibri"/>
+              </a:rPr>
+              <a:t>I</a:t>
+            </a:r>
+            <a:r>
+              <a:rPr sz="1800" b="1">
+                <a:solidFill>
+                  <a:srgbClr val="502379"/>
+                </a:solidFill>
+                <a:latin typeface="Calibri"/>
+              </a:rPr>
+              <a:t>NTROVERTS</a:t>
+            </a:r>
+          </a:p>
+          <a:p>
+            <a:pPr>
               <a:lnSpc>
                 <a:spcPct val="115000"/>
               </a:lnSpc>
               <a:spcAft>
-                <a:spcPts val="400"/>
+                <a:spcPts val="0"/>
               </a:spcAft>
             </a:pPr>
             <a:r>
-              <a:rPr sz="1600" b="1" i="0">
-                <a:solidFill>
-                  <a:srgbClr val="502379"/>
+              <a:rPr sz="1500" b="0">
+                <a:solidFill>
+                  <a:srgbClr val="E74C3C"/>
                 </a:solidFill>
                 <a:latin typeface="Calibri"/>
               </a:rPr>
-              <a:t>I - Introverts (</a:t>
-            </a:r>
-          </a:p>
-          <a:p>
-            <a:pPr algn="l">
-              <a:lnSpc>
-                <a:spcPct val="115000"/>
-              </a:lnSpc>
-              <a:spcAft>
-                <a:spcPts val="400"/>
-              </a:spcAft>
-            </a:pPr>
-            <a:r>
-              <a:rPr sz="1600" b="0" i="0">
+              <a:t>I</a:t>
+            </a:r>
+            <a:r>
+              <a:rPr sz="1500" b="0">
                 <a:solidFill>
                   <a:srgbClr val="222222"/>
                 </a:solidFill>
                 <a:latin typeface="Calibri"/>
               </a:rPr>
-              <a:t>Introverts are energised by spending time alone. They are inclined to think things through without speaking and are more private about their feelings.</a:t>
+              <a:t>ntroverts are energised by spending time alone. They are inclined to think things through without speaking and are more private about their feelings.</a:t>
             </a:r>
           </a:p>
         </p:txBody>
@@ -4143,7 +4179,7 @@
         <p:spPr>
           <a:xfrm>
             <a:off x="868680" y="1737360"/>
-            <a:ext cx="10515600" cy="2011680"/>
+            <a:ext cx="10515600" cy="1920240"/>
           </a:xfrm>
           <a:prstGeom prst="rect">
             <a:avLst/>
@@ -4151,46 +4187,64 @@
           <a:noFill/>
         </p:spPr>
         <p:txBody>
-          <a:bodyPr wrap="square" anchor="t">
+          <a:bodyPr wrap="square">
             <a:spAutoFit/>
           </a:bodyPr>
           <a:lstStyle/>
           <a:p>
-            <a:pPr algn="l">
+            <a:pPr>
+              <a:lnSpc>
+                <a:spcPct val="110000"/>
+              </a:lnSpc>
+              <a:spcAft>
+                <a:spcPts val="200"/>
+              </a:spcAft>
+            </a:pPr>
+            <a:r>
+              <a:rPr sz="1800" b="1">
+                <a:solidFill>
+                  <a:srgbClr val="E74C3C"/>
+                </a:solidFill>
+                <a:latin typeface="Calibri"/>
+              </a:rPr>
+              <a:t>S</a:t>
+            </a:r>
+            <a:r>
+              <a:rPr sz="1800" b="1">
+                <a:solidFill>
+                  <a:srgbClr val="502379"/>
+                </a:solidFill>
+                <a:latin typeface="Calibri"/>
+              </a:rPr>
+              <a:t>ENSING</a:t>
+            </a:r>
+          </a:p>
+          <a:p>
+            <a:pPr>
               <a:lnSpc>
                 <a:spcPct val="115000"/>
               </a:lnSpc>
               <a:spcAft>
-                <a:spcPts val="400"/>
+                <a:spcPts val="0"/>
               </a:spcAft>
             </a:pPr>
             <a:r>
-              <a:rPr sz="1600" b="1" i="0">
-                <a:solidFill>
-                  <a:srgbClr val="502379"/>
+              <a:rPr sz="1500" b="0">
+                <a:solidFill>
+                  <a:srgbClr val="E74C3C"/>
                 </a:solidFill>
                 <a:latin typeface="Calibri"/>
               </a:rPr>
-              <a:t>S - Sensing (</a:t>
-            </a:r>
-          </a:p>
-          <a:p>
-            <a:pPr algn="l">
-              <a:lnSpc>
-                <a:spcPct val="115000"/>
-              </a:lnSpc>
-              <a:spcAft>
-                <a:spcPts val="400"/>
-              </a:spcAft>
-            </a:pPr>
-            <a:r>
-              <a:rPr sz="1600" b="0" i="0">
+              <a:t>S</a:t>
+            </a:r>
+            <a:r>
+              <a:rPr sz="1500" b="0">
                 <a:solidFill>
                   <a:srgbClr val="222222"/>
                 </a:solidFill>
                 <a:latin typeface="Calibri"/>
               </a:rPr>
-              <a:t>Sensing types trust what is certain and concrete. They like new ideas only if they are practical. They value realism and common sense and like to use established skills.</a:t>
+              <a:t>ensing types trust what is certain and concrete. They like new ideas only if they are practical. They value realism and common sense and like to use established skills.</a:t>
             </a:r>
           </a:p>
         </p:txBody>
@@ -4250,7 +4304,7 @@
         <p:spPr>
           <a:xfrm>
             <a:off x="868680" y="4206240"/>
-            <a:ext cx="10515600" cy="2011680"/>
+            <a:ext cx="10515600" cy="1920240"/>
           </a:xfrm>
           <a:prstGeom prst="rect">
             <a:avLst/>
@@ -4258,46 +4312,64 @@
           <a:noFill/>
         </p:spPr>
         <p:txBody>
-          <a:bodyPr wrap="square" anchor="t">
+          <a:bodyPr wrap="square">
             <a:spAutoFit/>
           </a:bodyPr>
           <a:lstStyle/>
           <a:p>
-            <a:pPr algn="l">
+            <a:pPr>
+              <a:lnSpc>
+                <a:spcPct val="110000"/>
+              </a:lnSpc>
+              <a:spcAft>
+                <a:spcPts val="200"/>
+              </a:spcAft>
+            </a:pPr>
+            <a:r>
+              <a:rPr sz="1800" b="1">
+                <a:solidFill>
+                  <a:srgbClr val="E74C3C"/>
+                </a:solidFill>
+                <a:latin typeface="Calibri"/>
+              </a:rPr>
+              <a:t>I</a:t>
+            </a:r>
+            <a:r>
+              <a:rPr sz="1800" b="1">
+                <a:solidFill>
+                  <a:srgbClr val="502379"/>
+                </a:solidFill>
+                <a:latin typeface="Calibri"/>
+              </a:rPr>
+              <a:t>NTUITION</a:t>
+            </a:r>
+          </a:p>
+          <a:p>
+            <a:pPr>
               <a:lnSpc>
                 <a:spcPct val="115000"/>
               </a:lnSpc>
               <a:spcAft>
-                <a:spcPts val="400"/>
+                <a:spcPts val="0"/>
               </a:spcAft>
             </a:pPr>
             <a:r>
-              <a:rPr sz="1600" b="1" i="0">
-                <a:solidFill>
-                  <a:srgbClr val="502379"/>
+              <a:rPr sz="1500" b="0">
+                <a:solidFill>
+                  <a:srgbClr val="E74C3C"/>
                 </a:solidFill>
                 <a:latin typeface="Calibri"/>
               </a:rPr>
-              <a:t>N - Intuition (</a:t>
-            </a:r>
-          </a:p>
-          <a:p>
-            <a:pPr algn="l">
-              <a:lnSpc>
-                <a:spcPct val="115000"/>
-              </a:lnSpc>
-              <a:spcAft>
-                <a:spcPts val="400"/>
-              </a:spcAft>
-            </a:pPr>
-            <a:r>
-              <a:rPr sz="1600" b="0" i="0">
+              <a:t>I</a:t>
+            </a:r>
+            <a:r>
+              <a:rPr sz="1500" b="0">
                 <a:solidFill>
                   <a:srgbClr val="222222"/>
                 </a:solidFill>
                 <a:latin typeface="Calibri"/>
               </a:rPr>
-              <a:t>Intuition types trust their instincts, inspiration and inference. They like new ideas for their own sake. They value imagination and innovation and like to learn new skills.</a:t>
+              <a:t>ntuition types trust their instincts, inspiration and inference. They like new ideas for their own sake. They value imagination and innovation and like to learn new skills.</a:t>
             </a:r>
           </a:p>
         </p:txBody>
@@ -4503,7 +4575,7 @@
         <p:spPr>
           <a:xfrm>
             <a:off x="868680" y="1737360"/>
-            <a:ext cx="10515600" cy="2011680"/>
+            <a:ext cx="10515600" cy="1920240"/>
           </a:xfrm>
           <a:prstGeom prst="rect">
             <a:avLst/>
@@ -4511,46 +4583,64 @@
           <a:noFill/>
         </p:spPr>
         <p:txBody>
-          <a:bodyPr wrap="square" anchor="t">
+          <a:bodyPr wrap="square">
             <a:spAutoFit/>
           </a:bodyPr>
           <a:lstStyle/>
           <a:p>
-            <a:pPr algn="l">
+            <a:pPr>
+              <a:lnSpc>
+                <a:spcPct val="110000"/>
+              </a:lnSpc>
+              <a:spcAft>
+                <a:spcPts val="200"/>
+              </a:spcAft>
+            </a:pPr>
+            <a:r>
+              <a:rPr sz="1800" b="1">
+                <a:solidFill>
+                  <a:srgbClr val="E74C3C"/>
+                </a:solidFill>
+                <a:latin typeface="Calibri"/>
+              </a:rPr>
+              <a:t>T</a:t>
+            </a:r>
+            <a:r>
+              <a:rPr sz="1800" b="1">
+                <a:solidFill>
+                  <a:srgbClr val="502379"/>
+                </a:solidFill>
+                <a:latin typeface="Calibri"/>
+              </a:rPr>
+              <a:t>HINKING</a:t>
+            </a:r>
+          </a:p>
+          <a:p>
+            <a:pPr>
               <a:lnSpc>
                 <a:spcPct val="115000"/>
               </a:lnSpc>
               <a:spcAft>
-                <a:spcPts val="400"/>
+                <a:spcPts val="0"/>
               </a:spcAft>
             </a:pPr>
             <a:r>
-              <a:rPr sz="1600" b="1" i="0">
-                <a:solidFill>
-                  <a:srgbClr val="502379"/>
+              <a:rPr sz="1500" b="0">
+                <a:solidFill>
+                  <a:srgbClr val="E74C3C"/>
                 </a:solidFill>
                 <a:latin typeface="Calibri"/>
               </a:rPr>
-              <a:t>T - Thinking (</a:t>
-            </a:r>
-          </a:p>
-          <a:p>
-            <a:pPr algn="l">
-              <a:lnSpc>
-                <a:spcPct val="115000"/>
-              </a:lnSpc>
-              <a:spcAft>
-                <a:spcPts val="400"/>
-              </a:spcAft>
-            </a:pPr>
-            <a:r>
-              <a:rPr sz="1600" b="0" i="0">
+              <a:t>T</a:t>
+            </a:r>
+            <a:r>
+              <a:rPr sz="1500" b="0">
                 <a:solidFill>
                   <a:srgbClr val="222222"/>
                 </a:solidFill>
                 <a:latin typeface="Calibri"/>
               </a:rPr>
-              <a:t>Thinking types step back from problems and analyse them. They believe truth is more important than tact. They have strong motivation to achieve.</a:t>
+              <a:t>hinking types step back from problems and analyse them. They believe truth is more important than tact. They have strong motivation to achieve.</a:t>
             </a:r>
           </a:p>
         </p:txBody>
@@ -4610,7 +4700,7 @@
         <p:spPr>
           <a:xfrm>
             <a:off x="868680" y="4206240"/>
-            <a:ext cx="10515600" cy="2011680"/>
+            <a:ext cx="10515600" cy="1920240"/>
           </a:xfrm>
           <a:prstGeom prst="rect">
             <a:avLst/>
@@ -4618,46 +4708,64 @@
           <a:noFill/>
         </p:spPr>
         <p:txBody>
-          <a:bodyPr wrap="square" anchor="t">
+          <a:bodyPr wrap="square">
             <a:spAutoFit/>
           </a:bodyPr>
           <a:lstStyle/>
           <a:p>
-            <a:pPr algn="l">
+            <a:pPr>
+              <a:lnSpc>
+                <a:spcPct val="110000"/>
+              </a:lnSpc>
+              <a:spcAft>
+                <a:spcPts val="200"/>
+              </a:spcAft>
+            </a:pPr>
+            <a:r>
+              <a:rPr sz="1800" b="1">
+                <a:solidFill>
+                  <a:srgbClr val="E74C3C"/>
+                </a:solidFill>
+                <a:latin typeface="Calibri"/>
+              </a:rPr>
+              <a:t>F</a:t>
+            </a:r>
+            <a:r>
+              <a:rPr sz="1800" b="1">
+                <a:solidFill>
+                  <a:srgbClr val="502379"/>
+                </a:solidFill>
+                <a:latin typeface="Calibri"/>
+              </a:rPr>
+              <a:t>EELING</a:t>
+            </a:r>
+          </a:p>
+          <a:p>
+            <a:pPr>
               <a:lnSpc>
                 <a:spcPct val="115000"/>
               </a:lnSpc>
               <a:spcAft>
-                <a:spcPts val="400"/>
+                <a:spcPts val="0"/>
               </a:spcAft>
             </a:pPr>
             <a:r>
-              <a:rPr sz="1600" b="1" i="0">
-                <a:solidFill>
-                  <a:srgbClr val="502379"/>
+              <a:rPr sz="1500" b="0">
+                <a:solidFill>
+                  <a:srgbClr val="E74C3C"/>
                 </a:solidFill>
                 <a:latin typeface="Calibri"/>
               </a:rPr>
-              <a:t>F - Feeling (</a:t>
-            </a:r>
-          </a:p>
-          <a:p>
-            <a:pPr algn="l">
-              <a:lnSpc>
-                <a:spcPct val="115000"/>
-              </a:lnSpc>
-              <a:spcAft>
-                <a:spcPts val="400"/>
-              </a:spcAft>
-            </a:pPr>
-            <a:r>
-              <a:rPr sz="1600" b="0" i="0">
+              <a:t>F</a:t>
+            </a:r>
+            <a:r>
+              <a:rPr sz="1500" b="0">
                 <a:solidFill>
                   <a:srgbClr val="222222"/>
                 </a:solidFill>
                 <a:latin typeface="Calibri"/>
               </a:rPr>
-              <a:t>Feeling types think hard about the effects of decisions on individuals. They look for compromises and believe feelings are more important in decision making.</a:t>
+              <a:t>eeling types think hard about the effects of decisions on individuals. They look for compromises and believe feelings are more important in decision making.</a:t>
             </a:r>
           </a:p>
         </p:txBody>
@@ -4863,7 +4971,7 @@
         <p:spPr>
           <a:xfrm>
             <a:off x="868680" y="1737360"/>
-            <a:ext cx="10515600" cy="2011680"/>
+            <a:ext cx="10515600" cy="1920240"/>
           </a:xfrm>
           <a:prstGeom prst="rect">
             <a:avLst/>
@@ -4871,46 +4979,64 @@
           <a:noFill/>
         </p:spPr>
         <p:txBody>
-          <a:bodyPr wrap="square" anchor="t">
+          <a:bodyPr wrap="square">
             <a:spAutoFit/>
           </a:bodyPr>
           <a:lstStyle/>
           <a:p>
-            <a:pPr algn="l">
+            <a:pPr>
+              <a:lnSpc>
+                <a:spcPct val="110000"/>
+              </a:lnSpc>
+              <a:spcAft>
+                <a:spcPts val="200"/>
+              </a:spcAft>
+            </a:pPr>
+            <a:r>
+              <a:rPr sz="1800" b="1">
+                <a:solidFill>
+                  <a:srgbClr val="E74C3C"/>
+                </a:solidFill>
+                <a:latin typeface="Calibri"/>
+              </a:rPr>
+              <a:t>J</a:t>
+            </a:r>
+            <a:r>
+              <a:rPr sz="1800" b="1">
+                <a:solidFill>
+                  <a:srgbClr val="502379"/>
+                </a:solidFill>
+                <a:latin typeface="Calibri"/>
+              </a:rPr>
+              <a:t>UDGEMENT</a:t>
+            </a:r>
+          </a:p>
+          <a:p>
+            <a:pPr>
               <a:lnSpc>
                 <a:spcPct val="115000"/>
               </a:lnSpc>
               <a:spcAft>
-                <a:spcPts val="400"/>
+                <a:spcPts val="0"/>
               </a:spcAft>
             </a:pPr>
             <a:r>
-              <a:rPr sz="1600" b="1" i="0">
-                <a:solidFill>
-                  <a:srgbClr val="502379"/>
+              <a:rPr sz="1500" b="0">
+                <a:solidFill>
+                  <a:srgbClr val="E74C3C"/>
                 </a:solidFill>
                 <a:latin typeface="Calibri"/>
               </a:rPr>
-              <a:t>J - Judgement (</a:t>
-            </a:r>
-          </a:p>
-          <a:p>
-            <a:pPr algn="l">
-              <a:lnSpc>
-                <a:spcPct val="115000"/>
-              </a:lnSpc>
-              <a:spcAft>
-                <a:spcPts val="400"/>
-              </a:spcAft>
-            </a:pPr>
-            <a:r>
-              <a:rPr sz="1600" b="0" i="0">
+              <a:t>J</a:t>
+            </a:r>
+            <a:r>
+              <a:rPr sz="1500" b="0">
                 <a:solidFill>
                   <a:srgbClr val="222222"/>
                 </a:solidFill>
                 <a:latin typeface="Calibri"/>
               </a:rPr>
-              <a:t>Judgement types are happiest after decisions are made. They set goals and work towards these, and prefer knowing exactly what is involved.</a:t>
+              <a:t>udgement types are happiest after decisions are made. They set goals and work towards these, and prefer knowing exactly what is involved.</a:t>
             </a:r>
           </a:p>
         </p:txBody>
@@ -4970,7 +5096,7 @@
         <p:spPr>
           <a:xfrm>
             <a:off x="868680" y="4206240"/>
-            <a:ext cx="10515600" cy="2011680"/>
+            <a:ext cx="10515600" cy="1920240"/>
           </a:xfrm>
           <a:prstGeom prst="rect">
             <a:avLst/>
@@ -4978,46 +5104,64 @@
           <a:noFill/>
         </p:spPr>
         <p:txBody>
-          <a:bodyPr wrap="square" anchor="t">
+          <a:bodyPr wrap="square">
             <a:spAutoFit/>
           </a:bodyPr>
           <a:lstStyle/>
           <a:p>
-            <a:pPr algn="l">
+            <a:pPr>
+              <a:lnSpc>
+                <a:spcPct val="110000"/>
+              </a:lnSpc>
+              <a:spcAft>
+                <a:spcPts val="200"/>
+              </a:spcAft>
+            </a:pPr>
+            <a:r>
+              <a:rPr sz="1800" b="1">
+                <a:solidFill>
+                  <a:srgbClr val="E74C3C"/>
+                </a:solidFill>
+                <a:latin typeface="Calibri"/>
+              </a:rPr>
+              <a:t>P</a:t>
+            </a:r>
+            <a:r>
+              <a:rPr sz="1800" b="1">
+                <a:solidFill>
+                  <a:srgbClr val="502379"/>
+                </a:solidFill>
+                <a:latin typeface="Calibri"/>
+              </a:rPr>
+              <a:t>ERCEPTION</a:t>
+            </a:r>
+          </a:p>
+          <a:p>
+            <a:pPr>
               <a:lnSpc>
                 <a:spcPct val="115000"/>
               </a:lnSpc>
               <a:spcAft>
-                <a:spcPts val="400"/>
+                <a:spcPts val="0"/>
               </a:spcAft>
             </a:pPr>
             <a:r>
-              <a:rPr sz="1600" b="1" i="0">
-                <a:solidFill>
-                  <a:srgbClr val="502379"/>
+              <a:rPr sz="1500" b="0">
+                <a:solidFill>
+                  <a:srgbClr val="E74C3C"/>
                 </a:solidFill>
                 <a:latin typeface="Calibri"/>
               </a:rPr>
-              <a:t>P - Perception (</a:t>
-            </a:r>
-          </a:p>
-          <a:p>
-            <a:pPr algn="l">
-              <a:lnSpc>
-                <a:spcPct val="115000"/>
-              </a:lnSpc>
-              <a:spcAft>
-                <a:spcPts val="400"/>
-              </a:spcAft>
-            </a:pPr>
-            <a:r>
-              <a:rPr sz="1600" b="0" i="0">
+              <a:t>P</a:t>
+            </a:r>
+            <a:r>
+              <a:rPr sz="1500" b="0">
                 <a:solidFill>
                   <a:srgbClr val="222222"/>
                 </a:solidFill>
                 <a:latin typeface="Calibri"/>
               </a:rPr>
-              <a:t>Perception types prefer to leave options open. They enjoy adapting to new situations and cope well with ambiguity.</a:t>
+              <a:t>erception types prefer to leave options open. They enjoy adapting to new situations and cope well with ambiguity.</a:t>
             </a:r>
           </a:p>
         </p:txBody>

</xml_diff>

<commit_message>
Unify Q2-Q4 slide format with Q1 (32pt title, 40pt option, 20pt desc)
</commit_message>
<xml_diff>
--- a/Effective_Teamwork_2_survey.pptx
+++ b/Effective_Teamwork_2_survey.pptx
@@ -3602,23 +3602,67 @@
       <p:grpSpPr/>
       <p:sp>
         <p:nvSpPr>
-          <p:cNvPr id="2" name="Rectangle 1"/>
+          <p:cNvPr id="2" name="TextBox 1"/>
+          <p:cNvSpPr txBox="1"/>
+          <p:nvPr/>
+        </p:nvSpPr>
+        <p:spPr>
+          <a:xfrm>
+            <a:off x="640080" y="466344"/>
+            <a:ext cx="11338560" cy="731520"/>
+          </a:xfrm>
+          <a:prstGeom prst="rect">
+            <a:avLst/>
+          </a:prstGeom>
+          <a:noFill/>
+        </p:spPr>
+        <p:txBody>
+          <a:bodyPr wrap="square" anchor="t">
+            <a:spAutoFit/>
+          </a:bodyPr>
+          <a:lstStyle/>
+          <a:p>
+            <a:pPr algn="l">
+              <a:lnSpc>
+                <a:spcPct val="100000"/>
+              </a:lnSpc>
+              <a:spcAft>
+                <a:spcPts val="0"/>
+              </a:spcAft>
+            </a:pPr>
+            <a:r>
+              <a:rPr sz="3200" b="1" i="0">
+                <a:solidFill>
+                  <a:srgbClr val="7030A0"/>
+                </a:solidFill>
+                <a:latin typeface="Calibri"/>
+              </a:rPr>
+              <a:t>Q1 - Where do you focus your attention?</a:t>
+            </a:r>
+          </a:p>
+        </p:txBody>
+      </p:sp>
+      <p:sp>
+        <p:nvSpPr>
+          <p:cNvPr id="3" name="Rectangle 2"/>
           <p:cNvSpPr/>
           <p:nvPr/>
         </p:nvSpPr>
         <p:spPr>
           <a:xfrm>
-            <a:off x="0" y="0"/>
-            <a:ext cx="201168" cy="6858000"/>
+            <a:off x="640080" y="1417320"/>
+            <a:ext cx="10972800" cy="2286000"/>
           </a:xfrm>
           <a:prstGeom prst="rect">
             <a:avLst/>
           </a:prstGeom>
           <a:solidFill>
-            <a:srgbClr val="502379"/>
+            <a:srgbClr val="F5F0FA"/>
           </a:solidFill>
-          <a:ln>
-            <a:noFill/>
+          <a:ln w="15240">
+            <a:solidFill>
+              <a:srgbClr val="7C3A9E"/>
+            </a:solidFill>
           </a:ln>
           <a:effectLst/>
         </p:spPr>
@@ -3646,14 +3690,14 @@
       </p:sp>
       <p:sp>
         <p:nvSpPr>
-          <p:cNvPr id="3" name="TextBox 2"/>
+          <p:cNvPr id="4" name="TextBox 3"/>
           <p:cNvSpPr txBox="1"/>
           <p:nvPr/>
         </p:nvSpPr>
         <p:spPr>
           <a:xfrm>
-            <a:off x="502920" y="274320"/>
-            <a:ext cx="11338560" cy="822960"/>
+            <a:off x="868680" y="1554480"/>
+            <a:ext cx="10515600" cy="2011680"/>
           </a:xfrm>
           <a:prstGeom prst="rect">
             <a:avLst/>
@@ -3661,69 +3705,55 @@
           <a:noFill/>
         </p:spPr>
         <p:txBody>
-          <a:bodyPr wrap="square" anchor="t">
+          <a:bodyPr wrap="square">
             <a:spAutoFit/>
           </a:bodyPr>
           <a:lstStyle/>
           <a:p>
-            <a:pPr algn="l">
+            <a:pPr>
               <a:lnSpc>
                 <a:spcPct val="100000"/>
               </a:lnSpc>
               <a:spcAft>
-                <a:spcPts val="600"/>
+                <a:spcPts val="400"/>
               </a:spcAft>
             </a:pPr>
             <a:r>
-              <a:rPr sz="2800" b="1" i="0">
-                <a:solidFill>
-                  <a:srgbClr val="502379"/>
+              <a:rPr sz="4000" b="1">
+                <a:solidFill>
+                  <a:srgbClr val="E74C3C"/>
                 </a:solidFill>
                 <a:latin typeface="Calibri"/>
               </a:rPr>
-              <a:t>Question 1 of 4</a:t>
-            </a:r>
-          </a:p>
-        </p:txBody>
-      </p:sp>
-      <p:sp>
-        <p:nvSpPr>
-          <p:cNvPr id="4" name="TextBox 3"/>
-          <p:cNvSpPr txBox="1"/>
-          <p:nvPr/>
-        </p:nvSpPr>
-        <p:spPr>
-          <a:xfrm>
-            <a:off x="502920" y="960120"/>
-            <a:ext cx="11338560" cy="457200"/>
-          </a:xfrm>
-          <a:prstGeom prst="rect">
-            <a:avLst/>
-          </a:prstGeom>
-          <a:noFill/>
-        </p:spPr>
-        <p:txBody>
-          <a:bodyPr wrap="square" anchor="t">
-            <a:spAutoFit/>
-          </a:bodyPr>
-          <a:lstStyle/>
-          <a:p>
-            <a:pPr algn="l">
+              <a:t>E</a:t>
+            </a:r>
+            <a:r>
+              <a:rPr sz="4000" b="1">
+                <a:solidFill>
+                  <a:srgbClr val="502379"/>
+                </a:solidFill>
+                <a:latin typeface="Calibri"/>
+              </a:rPr>
+              <a:t>XTROVERTS</a:t>
+            </a:r>
+          </a:p>
+          <a:p>
+            <a:pPr>
               <a:lnSpc>
-                <a:spcPct val="100000"/>
+                <a:spcPct val="110000"/>
               </a:lnSpc>
               <a:spcAft>
-                <a:spcPts val="600"/>
+                <a:spcPts val="0"/>
               </a:spcAft>
             </a:pPr>
             <a:r>
-              <a:rPr sz="1300" b="0" i="0">
-                <a:solidFill>
-                  <a:srgbClr val="666666"/>
+              <a:rPr sz="2000" b="0">
+                <a:solidFill>
+                  <a:srgbClr val="222222"/>
                 </a:solidFill>
                 <a:latin typeface="Calibri"/>
               </a:rPr>
-              <a:t>Where do you focus your attention?</a:t>
+              <a:t>Extroverts are energised by being with others. Often think out loud and share their personal feelings easily.</a:t>
             </a:r>
           </a:p>
         </p:txBody>
@@ -3736,7 +3766,7 @@
         </p:nvSpPr>
         <p:spPr>
           <a:xfrm>
-            <a:off x="640080" y="1554480"/>
+            <a:off x="640080" y="4023360"/>
             <a:ext cx="10972800" cy="2286000"/>
           </a:xfrm>
           <a:prstGeom prst="rect">
@@ -3782,8 +3812,8 @@
         </p:nvSpPr>
         <p:spPr>
           <a:xfrm>
-            <a:off x="868680" y="1737360"/>
-            <a:ext cx="10515600" cy="1920240"/>
+            <a:off x="868680" y="4160520"/>
+            <a:ext cx="10515600" cy="2011680"/>
           </a:xfrm>
           <a:prstGeom prst="rect">
             <a:avLst/>
@@ -3795,185 +3825,51 @@
             <a:spAutoFit/>
           </a:bodyPr>
           <a:lstStyle/>
+          <a:p>
+            <a:pPr>
+              <a:lnSpc>
+                <a:spcPct val="100000"/>
+              </a:lnSpc>
+              <a:spcAft>
+                <a:spcPts val="400"/>
+              </a:spcAft>
+            </a:pPr>
+            <a:r>
+              <a:rPr sz="4000" b="1">
+                <a:solidFill>
+                  <a:srgbClr val="E74C3C"/>
+                </a:solidFill>
+                <a:latin typeface="Calibri"/>
+              </a:rPr>
+              <a:t>I</a:t>
+            </a:r>
+            <a:r>
+              <a:rPr sz="4000" b="1">
+                <a:solidFill>
+                  <a:srgbClr val="502379"/>
+                </a:solidFill>
+                <a:latin typeface="Calibri"/>
+              </a:rPr>
+              <a:t>NTROVERTS</a:t>
+            </a:r>
+          </a:p>
           <a:p>
             <a:pPr>
               <a:lnSpc>
                 <a:spcPct val="110000"/>
               </a:lnSpc>
               <a:spcAft>
-                <a:spcPts val="200"/>
-              </a:spcAft>
-            </a:pPr>
-            <a:r>
-              <a:rPr sz="1800" b="1">
-                <a:solidFill>
-                  <a:srgbClr val="E74C3C"/>
-                </a:solidFill>
-                <a:latin typeface="Calibri"/>
-              </a:rPr>
-              <a:t>E</a:t>
-            </a:r>
-            <a:r>
-              <a:rPr sz="1800" b="1">
-                <a:solidFill>
-                  <a:srgbClr val="502379"/>
-                </a:solidFill>
-                <a:latin typeface="Calibri"/>
-              </a:rPr>
-              <a:t>XTROVERTS</a:t>
-            </a:r>
-          </a:p>
-          <a:p>
-            <a:pPr>
-              <a:lnSpc>
-                <a:spcPct val="115000"/>
-              </a:lnSpc>
-              <a:spcAft>
                 <a:spcPts val="0"/>
               </a:spcAft>
             </a:pPr>
             <a:r>
-              <a:rPr sz="1500" b="0">
-                <a:solidFill>
-                  <a:srgbClr val="E74C3C"/>
+              <a:rPr sz="2000" b="0">
+                <a:solidFill>
+                  <a:srgbClr val="222222"/>
                 </a:solidFill>
                 <a:latin typeface="Calibri"/>
               </a:rPr>
-              <a:t>E</a:t>
-            </a:r>
-            <a:r>
-              <a:rPr sz="1500" b="0">
-                <a:solidFill>
-                  <a:srgbClr val="222222"/>
-                </a:solidFill>
-                <a:latin typeface="Calibri"/>
-              </a:rPr>
-              <a:t>xtroverts are energised by being with others. Often think out loud and share their personal feelings easily.</a:t>
-            </a:r>
-          </a:p>
-        </p:txBody>
-      </p:sp>
-      <p:sp>
-        <p:nvSpPr>
-          <p:cNvPr id="7" name="Rectangle 6"/>
-          <p:cNvSpPr/>
-          <p:nvPr/>
-        </p:nvSpPr>
-        <p:spPr>
-          <a:xfrm>
-            <a:off x="640080" y="4023360"/>
-            <a:ext cx="10972800" cy="2286000"/>
-          </a:xfrm>
-          <a:prstGeom prst="rect">
-            <a:avLst/>
-          </a:prstGeom>
-          <a:solidFill>
-            <a:srgbClr val="F5F0FA"/>
-          </a:solidFill>
-          <a:ln w="15240">
-            <a:solidFill>
-              <a:srgbClr val="7C3A9E"/>
-            </a:solidFill>
-          </a:ln>
-          <a:effectLst/>
-        </p:spPr>
-        <p:style>
-          <a:lnRef idx="1">
-            <a:schemeClr val="accent1"/>
-          </a:lnRef>
-          <a:fillRef idx="3">
-            <a:schemeClr val="accent1"/>
-          </a:fillRef>
-          <a:effectRef idx="2">
-            <a:schemeClr val="accent1"/>
-          </a:effectRef>
-          <a:fontRef idx="minor">
-            <a:schemeClr val="lt1"/>
-          </a:fontRef>
-        </p:style>
-        <p:txBody>
-          <a:bodyPr rtlCol="0" anchor="ctr"/>
-          <a:lstStyle/>
-          <a:p>
-            <a:pPr algn="ctr"/>
-          </a:p>
-        </p:txBody>
-      </p:sp>
-      <p:sp>
-        <p:nvSpPr>
-          <p:cNvPr id="8" name="TextBox 7"/>
-          <p:cNvSpPr txBox="1"/>
-          <p:nvPr/>
-        </p:nvSpPr>
-        <p:spPr>
-          <a:xfrm>
-            <a:off x="868680" y="4206240"/>
-            <a:ext cx="10515600" cy="1920240"/>
-          </a:xfrm>
-          <a:prstGeom prst="rect">
-            <a:avLst/>
-          </a:prstGeom>
-          <a:noFill/>
-        </p:spPr>
-        <p:txBody>
-          <a:bodyPr wrap="square">
-            <a:spAutoFit/>
-          </a:bodyPr>
-          <a:lstStyle/>
-          <a:p>
-            <a:pPr>
-              <a:lnSpc>
-                <a:spcPct val="110000"/>
-              </a:lnSpc>
-              <a:spcAft>
-                <a:spcPts val="200"/>
-              </a:spcAft>
-            </a:pPr>
-            <a:r>
-              <a:rPr sz="1800" b="1">
-                <a:solidFill>
-                  <a:srgbClr val="E74C3C"/>
-                </a:solidFill>
-                <a:latin typeface="Calibri"/>
-              </a:rPr>
-              <a:t>I</a:t>
-            </a:r>
-            <a:r>
-              <a:rPr sz="1800" b="1">
-                <a:solidFill>
-                  <a:srgbClr val="502379"/>
-                </a:solidFill>
-                <a:latin typeface="Calibri"/>
-              </a:rPr>
-              <a:t>NTROVERTS</a:t>
-            </a:r>
-          </a:p>
-          <a:p>
-            <a:pPr>
-              <a:lnSpc>
-                <a:spcPct val="115000"/>
-              </a:lnSpc>
-              <a:spcAft>
-                <a:spcPts val="0"/>
-              </a:spcAft>
-            </a:pPr>
-            <a:r>
-              <a:rPr sz="1500" b="0">
-                <a:solidFill>
-                  <a:srgbClr val="E74C3C"/>
-                </a:solidFill>
-                <a:latin typeface="Calibri"/>
-              </a:rPr>
-              <a:t>I</a:t>
-            </a:r>
-            <a:r>
-              <a:rPr sz="1500" b="0">
-                <a:solidFill>
-                  <a:srgbClr val="222222"/>
-                </a:solidFill>
-                <a:latin typeface="Calibri"/>
-              </a:rPr>
-              <a:t>ntroverts are energised by spending time alone. They are inclined to think things through without speaking and are more private about their feelings.</a:t>
+              <a:t>Introverts are energised by spending time alone. They are inclined to think things through without speaking and are more private about their feelings.</a:t>
             </a:r>
           </a:p>
         </p:txBody>
@@ -3998,23 +3894,67 @@
       <p:grpSpPr/>
       <p:sp>
         <p:nvSpPr>
-          <p:cNvPr id="2" name="Rectangle 1"/>
+          <p:cNvPr id="2" name="TextBox 1"/>
+          <p:cNvSpPr txBox="1"/>
+          <p:nvPr/>
+        </p:nvSpPr>
+        <p:spPr>
+          <a:xfrm>
+            <a:off x="640080" y="466344"/>
+            <a:ext cx="11338560" cy="731520"/>
+          </a:xfrm>
+          <a:prstGeom prst="rect">
+            <a:avLst/>
+          </a:prstGeom>
+          <a:noFill/>
+        </p:spPr>
+        <p:txBody>
+          <a:bodyPr wrap="square" anchor="t">
+            <a:spAutoFit/>
+          </a:bodyPr>
+          <a:lstStyle/>
+          <a:p>
+            <a:pPr algn="l">
+              <a:lnSpc>
+                <a:spcPct val="100000"/>
+              </a:lnSpc>
+              <a:spcAft>
+                <a:spcPts val="0"/>
+              </a:spcAft>
+            </a:pPr>
+            <a:r>
+              <a:rPr sz="3200" b="1" i="0">
+                <a:solidFill>
+                  <a:srgbClr val="7030A0"/>
+                </a:solidFill>
+                <a:latin typeface="Calibri"/>
+              </a:rPr>
+              <a:t>Q2 - How do you take in information?</a:t>
+            </a:r>
+          </a:p>
+        </p:txBody>
+      </p:sp>
+      <p:sp>
+        <p:nvSpPr>
+          <p:cNvPr id="3" name="Rectangle 2"/>
           <p:cNvSpPr/>
           <p:nvPr/>
         </p:nvSpPr>
         <p:spPr>
           <a:xfrm>
-            <a:off x="0" y="0"/>
-            <a:ext cx="201168" cy="6858000"/>
+            <a:off x="640080" y="1417320"/>
+            <a:ext cx="10972800" cy="2286000"/>
           </a:xfrm>
           <a:prstGeom prst="rect">
             <a:avLst/>
           </a:prstGeom>
           <a:solidFill>
-            <a:srgbClr val="502379"/>
+            <a:srgbClr val="F5F0FA"/>
           </a:solidFill>
-          <a:ln>
-            <a:noFill/>
+          <a:ln w="15240">
+            <a:solidFill>
+              <a:srgbClr val="7C3A9E"/>
+            </a:solidFill>
           </a:ln>
           <a:effectLst/>
         </p:spPr>
@@ -4042,14 +3982,14 @@
       </p:sp>
       <p:sp>
         <p:nvSpPr>
-          <p:cNvPr id="3" name="TextBox 2"/>
+          <p:cNvPr id="4" name="TextBox 3"/>
           <p:cNvSpPr txBox="1"/>
           <p:nvPr/>
         </p:nvSpPr>
         <p:spPr>
           <a:xfrm>
-            <a:off x="502920" y="274320"/>
-            <a:ext cx="11338560" cy="822960"/>
+            <a:off x="868680" y="1554480"/>
+            <a:ext cx="10515600" cy="2011680"/>
           </a:xfrm>
           <a:prstGeom prst="rect">
             <a:avLst/>
@@ -4057,69 +3997,55 @@
           <a:noFill/>
         </p:spPr>
         <p:txBody>
-          <a:bodyPr wrap="square" anchor="t">
+          <a:bodyPr wrap="square">
             <a:spAutoFit/>
           </a:bodyPr>
           <a:lstStyle/>
           <a:p>
-            <a:pPr algn="l">
+            <a:pPr>
               <a:lnSpc>
                 <a:spcPct val="100000"/>
               </a:lnSpc>
               <a:spcAft>
-                <a:spcPts val="600"/>
+                <a:spcPts val="400"/>
               </a:spcAft>
             </a:pPr>
             <a:r>
-              <a:rPr sz="2800" b="1" i="0">
-                <a:solidFill>
-                  <a:srgbClr val="502379"/>
+              <a:rPr sz="4000" b="1">
+                <a:solidFill>
+                  <a:srgbClr val="E74C3C"/>
                 </a:solidFill>
                 <a:latin typeface="Calibri"/>
               </a:rPr>
-              <a:t>Question 2 of 4</a:t>
-            </a:r>
-          </a:p>
-        </p:txBody>
-      </p:sp>
-      <p:sp>
-        <p:nvSpPr>
-          <p:cNvPr id="4" name="TextBox 3"/>
-          <p:cNvSpPr txBox="1"/>
-          <p:nvPr/>
-        </p:nvSpPr>
-        <p:spPr>
-          <a:xfrm>
-            <a:off x="502920" y="960120"/>
-            <a:ext cx="11338560" cy="457200"/>
-          </a:xfrm>
-          <a:prstGeom prst="rect">
-            <a:avLst/>
-          </a:prstGeom>
-          <a:noFill/>
-        </p:spPr>
-        <p:txBody>
-          <a:bodyPr wrap="square" anchor="t">
-            <a:spAutoFit/>
-          </a:bodyPr>
-          <a:lstStyle/>
-          <a:p>
-            <a:pPr algn="l">
+              <a:t>S</a:t>
+            </a:r>
+            <a:r>
+              <a:rPr sz="4000" b="1">
+                <a:solidFill>
+                  <a:srgbClr val="502379"/>
+                </a:solidFill>
+                <a:latin typeface="Calibri"/>
+              </a:rPr>
+              <a:t>ENSING</a:t>
+            </a:r>
+          </a:p>
+          <a:p>
+            <a:pPr>
               <a:lnSpc>
-                <a:spcPct val="100000"/>
+                <a:spcPct val="110000"/>
               </a:lnSpc>
               <a:spcAft>
-                <a:spcPts val="600"/>
+                <a:spcPts val="0"/>
               </a:spcAft>
             </a:pPr>
             <a:r>
-              <a:rPr sz="1300" b="0" i="0">
-                <a:solidFill>
-                  <a:srgbClr val="666666"/>
+              <a:rPr sz="2000" b="0">
+                <a:solidFill>
+                  <a:srgbClr val="222222"/>
                 </a:solidFill>
                 <a:latin typeface="Calibri"/>
               </a:rPr>
-              <a:t>How do you take in information?</a:t>
+              <a:t>Sensing types trust what is certain and concrete. They like new ideas only if they are practical. They value realism and common sense and like to use established skills.</a:t>
             </a:r>
           </a:p>
         </p:txBody>
@@ -4132,7 +4058,7 @@
         </p:nvSpPr>
         <p:spPr>
           <a:xfrm>
-            <a:off x="640080" y="1554480"/>
+            <a:off x="640080" y="4023360"/>
             <a:ext cx="10972800" cy="2286000"/>
           </a:xfrm>
           <a:prstGeom prst="rect">
@@ -4178,8 +4104,8 @@
         </p:nvSpPr>
         <p:spPr>
           <a:xfrm>
-            <a:off x="868680" y="1737360"/>
-            <a:ext cx="10515600" cy="1920240"/>
+            <a:off x="868680" y="4160520"/>
+            <a:ext cx="10515600" cy="2011680"/>
           </a:xfrm>
           <a:prstGeom prst="rect">
             <a:avLst/>
@@ -4191,185 +4117,51 @@
             <a:spAutoFit/>
           </a:bodyPr>
           <a:lstStyle/>
+          <a:p>
+            <a:pPr>
+              <a:lnSpc>
+                <a:spcPct val="100000"/>
+              </a:lnSpc>
+              <a:spcAft>
+                <a:spcPts val="400"/>
+              </a:spcAft>
+            </a:pPr>
+            <a:r>
+              <a:rPr sz="4000" b="1">
+                <a:solidFill>
+                  <a:srgbClr val="E74C3C"/>
+                </a:solidFill>
+                <a:latin typeface="Calibri"/>
+              </a:rPr>
+              <a:t>I</a:t>
+            </a:r>
+            <a:r>
+              <a:rPr sz="4000" b="1">
+                <a:solidFill>
+                  <a:srgbClr val="502379"/>
+                </a:solidFill>
+                <a:latin typeface="Calibri"/>
+              </a:rPr>
+              <a:t>NTUITION</a:t>
+            </a:r>
+          </a:p>
           <a:p>
             <a:pPr>
               <a:lnSpc>
                 <a:spcPct val="110000"/>
               </a:lnSpc>
               <a:spcAft>
-                <a:spcPts val="200"/>
-              </a:spcAft>
-            </a:pPr>
-            <a:r>
-              <a:rPr sz="1800" b="1">
-                <a:solidFill>
-                  <a:srgbClr val="E74C3C"/>
-                </a:solidFill>
-                <a:latin typeface="Calibri"/>
-              </a:rPr>
-              <a:t>S</a:t>
-            </a:r>
-            <a:r>
-              <a:rPr sz="1800" b="1">
-                <a:solidFill>
-                  <a:srgbClr val="502379"/>
-                </a:solidFill>
-                <a:latin typeface="Calibri"/>
-              </a:rPr>
-              <a:t>ENSING</a:t>
-            </a:r>
-          </a:p>
-          <a:p>
-            <a:pPr>
-              <a:lnSpc>
-                <a:spcPct val="115000"/>
-              </a:lnSpc>
-              <a:spcAft>
                 <a:spcPts val="0"/>
               </a:spcAft>
             </a:pPr>
             <a:r>
-              <a:rPr sz="1500" b="0">
-                <a:solidFill>
-                  <a:srgbClr val="E74C3C"/>
+              <a:rPr sz="2000" b="0">
+                <a:solidFill>
+                  <a:srgbClr val="222222"/>
                 </a:solidFill>
                 <a:latin typeface="Calibri"/>
               </a:rPr>
-              <a:t>S</a:t>
-            </a:r>
-            <a:r>
-              <a:rPr sz="1500" b="0">
-                <a:solidFill>
-                  <a:srgbClr val="222222"/>
-                </a:solidFill>
-                <a:latin typeface="Calibri"/>
-              </a:rPr>
-              <a:t>ensing types trust what is certain and concrete. They like new ideas only if they are practical. They value realism and common sense and like to use established skills.</a:t>
-            </a:r>
-          </a:p>
-        </p:txBody>
-      </p:sp>
-      <p:sp>
-        <p:nvSpPr>
-          <p:cNvPr id="7" name="Rectangle 6"/>
-          <p:cNvSpPr/>
-          <p:nvPr/>
-        </p:nvSpPr>
-        <p:spPr>
-          <a:xfrm>
-            <a:off x="640080" y="4023360"/>
-            <a:ext cx="10972800" cy="2286000"/>
-          </a:xfrm>
-          <a:prstGeom prst="rect">
-            <a:avLst/>
-          </a:prstGeom>
-          <a:solidFill>
-            <a:srgbClr val="F5F0FA"/>
-          </a:solidFill>
-          <a:ln w="15240">
-            <a:solidFill>
-              <a:srgbClr val="7C3A9E"/>
-            </a:solidFill>
-          </a:ln>
-          <a:effectLst/>
-        </p:spPr>
-        <p:style>
-          <a:lnRef idx="1">
-            <a:schemeClr val="accent1"/>
-          </a:lnRef>
-          <a:fillRef idx="3">
-            <a:schemeClr val="accent1"/>
-          </a:fillRef>
-          <a:effectRef idx="2">
-            <a:schemeClr val="accent1"/>
-          </a:effectRef>
-          <a:fontRef idx="minor">
-            <a:schemeClr val="lt1"/>
-          </a:fontRef>
-        </p:style>
-        <p:txBody>
-          <a:bodyPr rtlCol="0" anchor="ctr"/>
-          <a:lstStyle/>
-          <a:p>
-            <a:pPr algn="ctr"/>
-          </a:p>
-        </p:txBody>
-      </p:sp>
-      <p:sp>
-        <p:nvSpPr>
-          <p:cNvPr id="8" name="TextBox 7"/>
-          <p:cNvSpPr txBox="1"/>
-          <p:nvPr/>
-        </p:nvSpPr>
-        <p:spPr>
-          <a:xfrm>
-            <a:off x="868680" y="4206240"/>
-            <a:ext cx="10515600" cy="1920240"/>
-          </a:xfrm>
-          <a:prstGeom prst="rect">
-            <a:avLst/>
-          </a:prstGeom>
-          <a:noFill/>
-        </p:spPr>
-        <p:txBody>
-          <a:bodyPr wrap="square">
-            <a:spAutoFit/>
-          </a:bodyPr>
-          <a:lstStyle/>
-          <a:p>
-            <a:pPr>
-              <a:lnSpc>
-                <a:spcPct val="110000"/>
-              </a:lnSpc>
-              <a:spcAft>
-                <a:spcPts val="200"/>
-              </a:spcAft>
-            </a:pPr>
-            <a:r>
-              <a:rPr sz="1800" b="1">
-                <a:solidFill>
-                  <a:srgbClr val="E74C3C"/>
-                </a:solidFill>
-                <a:latin typeface="Calibri"/>
-              </a:rPr>
-              <a:t>I</a:t>
-            </a:r>
-            <a:r>
-              <a:rPr sz="1800" b="1">
-                <a:solidFill>
-                  <a:srgbClr val="502379"/>
-                </a:solidFill>
-                <a:latin typeface="Calibri"/>
-              </a:rPr>
-              <a:t>NTUITION</a:t>
-            </a:r>
-          </a:p>
-          <a:p>
-            <a:pPr>
-              <a:lnSpc>
-                <a:spcPct val="115000"/>
-              </a:lnSpc>
-              <a:spcAft>
-                <a:spcPts val="0"/>
-              </a:spcAft>
-            </a:pPr>
-            <a:r>
-              <a:rPr sz="1500" b="0">
-                <a:solidFill>
-                  <a:srgbClr val="E74C3C"/>
-                </a:solidFill>
-                <a:latin typeface="Calibri"/>
-              </a:rPr>
-              <a:t>I</a:t>
-            </a:r>
-            <a:r>
-              <a:rPr sz="1500" b="0">
-                <a:solidFill>
-                  <a:srgbClr val="222222"/>
-                </a:solidFill>
-                <a:latin typeface="Calibri"/>
-              </a:rPr>
-              <a:t>ntuition types trust their instincts, inspiration and inference. They like new ideas for their own sake. They value imagination and innovation and like to learn new skills.</a:t>
+              <a:t>Intuition types trust their instincts, inspiration and inference. They like new ideas for their own sake. They value imagination and innovation and like to learn new skills.</a:t>
             </a:r>
           </a:p>
         </p:txBody>
@@ -4394,23 +4186,67 @@
       <p:grpSpPr/>
       <p:sp>
         <p:nvSpPr>
-          <p:cNvPr id="2" name="Rectangle 1"/>
+          <p:cNvPr id="2" name="TextBox 1"/>
+          <p:cNvSpPr txBox="1"/>
+          <p:nvPr/>
+        </p:nvSpPr>
+        <p:spPr>
+          <a:xfrm>
+            <a:off x="640080" y="466344"/>
+            <a:ext cx="11338560" cy="731520"/>
+          </a:xfrm>
+          <a:prstGeom prst="rect">
+            <a:avLst/>
+          </a:prstGeom>
+          <a:noFill/>
+        </p:spPr>
+        <p:txBody>
+          <a:bodyPr wrap="square" anchor="t">
+            <a:spAutoFit/>
+          </a:bodyPr>
+          <a:lstStyle/>
+          <a:p>
+            <a:pPr algn="l">
+              <a:lnSpc>
+                <a:spcPct val="100000"/>
+              </a:lnSpc>
+              <a:spcAft>
+                <a:spcPts val="0"/>
+              </a:spcAft>
+            </a:pPr>
+            <a:r>
+              <a:rPr sz="3200" b="1" i="0">
+                <a:solidFill>
+                  <a:srgbClr val="7030A0"/>
+                </a:solidFill>
+                <a:latin typeface="Calibri"/>
+              </a:rPr>
+              <a:t>Q3 - How do you make decisions?</a:t>
+            </a:r>
+          </a:p>
+        </p:txBody>
+      </p:sp>
+      <p:sp>
+        <p:nvSpPr>
+          <p:cNvPr id="3" name="Rectangle 2"/>
           <p:cNvSpPr/>
           <p:nvPr/>
         </p:nvSpPr>
         <p:spPr>
           <a:xfrm>
-            <a:off x="0" y="0"/>
-            <a:ext cx="201168" cy="6858000"/>
+            <a:off x="640080" y="1417320"/>
+            <a:ext cx="10972800" cy="2286000"/>
           </a:xfrm>
           <a:prstGeom prst="rect">
             <a:avLst/>
           </a:prstGeom>
           <a:solidFill>
-            <a:srgbClr val="502379"/>
+            <a:srgbClr val="F5F0FA"/>
           </a:solidFill>
-          <a:ln>
-            <a:noFill/>
+          <a:ln w="15240">
+            <a:solidFill>
+              <a:srgbClr val="7C3A9E"/>
+            </a:solidFill>
           </a:ln>
           <a:effectLst/>
         </p:spPr>
@@ -4438,14 +4274,14 @@
       </p:sp>
       <p:sp>
         <p:nvSpPr>
-          <p:cNvPr id="3" name="TextBox 2"/>
+          <p:cNvPr id="4" name="TextBox 3"/>
           <p:cNvSpPr txBox="1"/>
           <p:nvPr/>
         </p:nvSpPr>
         <p:spPr>
           <a:xfrm>
-            <a:off x="502920" y="274320"/>
-            <a:ext cx="11338560" cy="822960"/>
+            <a:off x="868680" y="1554480"/>
+            <a:ext cx="10515600" cy="2011680"/>
           </a:xfrm>
           <a:prstGeom prst="rect">
             <a:avLst/>
@@ -4453,69 +4289,55 @@
           <a:noFill/>
         </p:spPr>
         <p:txBody>
-          <a:bodyPr wrap="square" anchor="t">
+          <a:bodyPr wrap="square">
             <a:spAutoFit/>
           </a:bodyPr>
           <a:lstStyle/>
           <a:p>
-            <a:pPr algn="l">
+            <a:pPr>
               <a:lnSpc>
                 <a:spcPct val="100000"/>
               </a:lnSpc>
               <a:spcAft>
-                <a:spcPts val="600"/>
+                <a:spcPts val="400"/>
               </a:spcAft>
             </a:pPr>
             <a:r>
-              <a:rPr sz="2800" b="1" i="0">
-                <a:solidFill>
-                  <a:srgbClr val="502379"/>
+              <a:rPr sz="4000" b="1">
+                <a:solidFill>
+                  <a:srgbClr val="E74C3C"/>
                 </a:solidFill>
                 <a:latin typeface="Calibri"/>
               </a:rPr>
-              <a:t>Question 3 of 4</a:t>
-            </a:r>
-          </a:p>
-        </p:txBody>
-      </p:sp>
-      <p:sp>
-        <p:nvSpPr>
-          <p:cNvPr id="4" name="TextBox 3"/>
-          <p:cNvSpPr txBox="1"/>
-          <p:nvPr/>
-        </p:nvSpPr>
-        <p:spPr>
-          <a:xfrm>
-            <a:off x="502920" y="960120"/>
-            <a:ext cx="11338560" cy="457200"/>
-          </a:xfrm>
-          <a:prstGeom prst="rect">
-            <a:avLst/>
-          </a:prstGeom>
-          <a:noFill/>
-        </p:spPr>
-        <p:txBody>
-          <a:bodyPr wrap="square" anchor="t">
-            <a:spAutoFit/>
-          </a:bodyPr>
-          <a:lstStyle/>
-          <a:p>
-            <a:pPr algn="l">
+              <a:t>T</a:t>
+            </a:r>
+            <a:r>
+              <a:rPr sz="4000" b="1">
+                <a:solidFill>
+                  <a:srgbClr val="502379"/>
+                </a:solidFill>
+                <a:latin typeface="Calibri"/>
+              </a:rPr>
+              <a:t>HINKING</a:t>
+            </a:r>
+          </a:p>
+          <a:p>
+            <a:pPr>
               <a:lnSpc>
-                <a:spcPct val="100000"/>
+                <a:spcPct val="110000"/>
               </a:lnSpc>
               <a:spcAft>
-                <a:spcPts val="600"/>
+                <a:spcPts val="0"/>
               </a:spcAft>
             </a:pPr>
             <a:r>
-              <a:rPr sz="1300" b="0" i="0">
-                <a:solidFill>
-                  <a:srgbClr val="666666"/>
+              <a:rPr sz="2000" b="0">
+                <a:solidFill>
+                  <a:srgbClr val="222222"/>
                 </a:solidFill>
                 <a:latin typeface="Calibri"/>
               </a:rPr>
-              <a:t>How do you make decisions?</a:t>
+              <a:t>Thinking types step back from problems and analyse them. They believe truth is more important than tact. They have strong motivation to achieve.</a:t>
             </a:r>
           </a:p>
         </p:txBody>
@@ -4528,7 +4350,7 @@
         </p:nvSpPr>
         <p:spPr>
           <a:xfrm>
-            <a:off x="640080" y="1554480"/>
+            <a:off x="640080" y="4023360"/>
             <a:ext cx="10972800" cy="2286000"/>
           </a:xfrm>
           <a:prstGeom prst="rect">
@@ -4574,8 +4396,8 @@
         </p:nvSpPr>
         <p:spPr>
           <a:xfrm>
-            <a:off x="868680" y="1737360"/>
-            <a:ext cx="10515600" cy="1920240"/>
+            <a:off x="868680" y="4160520"/>
+            <a:ext cx="10515600" cy="2011680"/>
           </a:xfrm>
           <a:prstGeom prst="rect">
             <a:avLst/>
@@ -4587,185 +4409,51 @@
             <a:spAutoFit/>
           </a:bodyPr>
           <a:lstStyle/>
+          <a:p>
+            <a:pPr>
+              <a:lnSpc>
+                <a:spcPct val="100000"/>
+              </a:lnSpc>
+              <a:spcAft>
+                <a:spcPts val="400"/>
+              </a:spcAft>
+            </a:pPr>
+            <a:r>
+              <a:rPr sz="4000" b="1">
+                <a:solidFill>
+                  <a:srgbClr val="E74C3C"/>
+                </a:solidFill>
+                <a:latin typeface="Calibri"/>
+              </a:rPr>
+              <a:t>F</a:t>
+            </a:r>
+            <a:r>
+              <a:rPr sz="4000" b="1">
+                <a:solidFill>
+                  <a:srgbClr val="502379"/>
+                </a:solidFill>
+                <a:latin typeface="Calibri"/>
+              </a:rPr>
+              <a:t>EELING</a:t>
+            </a:r>
+          </a:p>
           <a:p>
             <a:pPr>
               <a:lnSpc>
                 <a:spcPct val="110000"/>
               </a:lnSpc>
               <a:spcAft>
-                <a:spcPts val="200"/>
-              </a:spcAft>
-            </a:pPr>
-            <a:r>
-              <a:rPr sz="1800" b="1">
-                <a:solidFill>
-                  <a:srgbClr val="E74C3C"/>
-                </a:solidFill>
-                <a:latin typeface="Calibri"/>
-              </a:rPr>
-              <a:t>T</a:t>
-            </a:r>
-            <a:r>
-              <a:rPr sz="1800" b="1">
-                <a:solidFill>
-                  <a:srgbClr val="502379"/>
-                </a:solidFill>
-                <a:latin typeface="Calibri"/>
-              </a:rPr>
-              <a:t>HINKING</a:t>
-            </a:r>
-          </a:p>
-          <a:p>
-            <a:pPr>
-              <a:lnSpc>
-                <a:spcPct val="115000"/>
-              </a:lnSpc>
-              <a:spcAft>
                 <a:spcPts val="0"/>
               </a:spcAft>
             </a:pPr>
             <a:r>
-              <a:rPr sz="1500" b="0">
-                <a:solidFill>
-                  <a:srgbClr val="E74C3C"/>
+              <a:rPr sz="2000" b="0">
+                <a:solidFill>
+                  <a:srgbClr val="222222"/>
                 </a:solidFill>
                 <a:latin typeface="Calibri"/>
               </a:rPr>
-              <a:t>T</a:t>
-            </a:r>
-            <a:r>
-              <a:rPr sz="1500" b="0">
-                <a:solidFill>
-                  <a:srgbClr val="222222"/>
-                </a:solidFill>
-                <a:latin typeface="Calibri"/>
-              </a:rPr>
-              <a:t>hinking types step back from problems and analyse them. They believe truth is more important than tact. They have strong motivation to achieve.</a:t>
-            </a:r>
-          </a:p>
-        </p:txBody>
-      </p:sp>
-      <p:sp>
-        <p:nvSpPr>
-          <p:cNvPr id="7" name="Rectangle 6"/>
-          <p:cNvSpPr/>
-          <p:nvPr/>
-        </p:nvSpPr>
-        <p:spPr>
-          <a:xfrm>
-            <a:off x="640080" y="4023360"/>
-            <a:ext cx="10972800" cy="2286000"/>
-          </a:xfrm>
-          <a:prstGeom prst="rect">
-            <a:avLst/>
-          </a:prstGeom>
-          <a:solidFill>
-            <a:srgbClr val="F5F0FA"/>
-          </a:solidFill>
-          <a:ln w="15240">
-            <a:solidFill>
-              <a:srgbClr val="7C3A9E"/>
-            </a:solidFill>
-          </a:ln>
-          <a:effectLst/>
-        </p:spPr>
-        <p:style>
-          <a:lnRef idx="1">
-            <a:schemeClr val="accent1"/>
-          </a:lnRef>
-          <a:fillRef idx="3">
-            <a:schemeClr val="accent1"/>
-          </a:fillRef>
-          <a:effectRef idx="2">
-            <a:schemeClr val="accent1"/>
-          </a:effectRef>
-          <a:fontRef idx="minor">
-            <a:schemeClr val="lt1"/>
-          </a:fontRef>
-        </p:style>
-        <p:txBody>
-          <a:bodyPr rtlCol="0" anchor="ctr"/>
-          <a:lstStyle/>
-          <a:p>
-            <a:pPr algn="ctr"/>
-          </a:p>
-        </p:txBody>
-      </p:sp>
-      <p:sp>
-        <p:nvSpPr>
-          <p:cNvPr id="8" name="TextBox 7"/>
-          <p:cNvSpPr txBox="1"/>
-          <p:nvPr/>
-        </p:nvSpPr>
-        <p:spPr>
-          <a:xfrm>
-            <a:off x="868680" y="4206240"/>
-            <a:ext cx="10515600" cy="1920240"/>
-          </a:xfrm>
-          <a:prstGeom prst="rect">
-            <a:avLst/>
-          </a:prstGeom>
-          <a:noFill/>
-        </p:spPr>
-        <p:txBody>
-          <a:bodyPr wrap="square">
-            <a:spAutoFit/>
-          </a:bodyPr>
-          <a:lstStyle/>
-          <a:p>
-            <a:pPr>
-              <a:lnSpc>
-                <a:spcPct val="110000"/>
-              </a:lnSpc>
-              <a:spcAft>
-                <a:spcPts val="200"/>
-              </a:spcAft>
-            </a:pPr>
-            <a:r>
-              <a:rPr sz="1800" b="1">
-                <a:solidFill>
-                  <a:srgbClr val="E74C3C"/>
-                </a:solidFill>
-                <a:latin typeface="Calibri"/>
-              </a:rPr>
-              <a:t>F</a:t>
-            </a:r>
-            <a:r>
-              <a:rPr sz="1800" b="1">
-                <a:solidFill>
-                  <a:srgbClr val="502379"/>
-                </a:solidFill>
-                <a:latin typeface="Calibri"/>
-              </a:rPr>
-              <a:t>EELING</a:t>
-            </a:r>
-          </a:p>
-          <a:p>
-            <a:pPr>
-              <a:lnSpc>
-                <a:spcPct val="115000"/>
-              </a:lnSpc>
-              <a:spcAft>
-                <a:spcPts val="0"/>
-              </a:spcAft>
-            </a:pPr>
-            <a:r>
-              <a:rPr sz="1500" b="0">
-                <a:solidFill>
-                  <a:srgbClr val="E74C3C"/>
-                </a:solidFill>
-                <a:latin typeface="Calibri"/>
-              </a:rPr>
-              <a:t>F</a:t>
-            </a:r>
-            <a:r>
-              <a:rPr sz="1500" b="0">
-                <a:solidFill>
-                  <a:srgbClr val="222222"/>
-                </a:solidFill>
-                <a:latin typeface="Calibri"/>
-              </a:rPr>
-              <a:t>eeling types think hard about the effects of decisions on individuals. They look for compromises and believe feelings are more important in decision making.</a:t>
+              <a:t>Feeling types think hard about the effects of decisions on individuals. They look for compromises and believe feelings are more important in decision making.</a:t>
             </a:r>
           </a:p>
         </p:txBody>
@@ -4790,23 +4478,67 @@
       <p:grpSpPr/>
       <p:sp>
         <p:nvSpPr>
-          <p:cNvPr id="2" name="Rectangle 1"/>
+          <p:cNvPr id="2" name="TextBox 1"/>
+          <p:cNvSpPr txBox="1"/>
+          <p:nvPr/>
+        </p:nvSpPr>
+        <p:spPr>
+          <a:xfrm>
+            <a:off x="640080" y="466344"/>
+            <a:ext cx="11338560" cy="731520"/>
+          </a:xfrm>
+          <a:prstGeom prst="rect">
+            <a:avLst/>
+          </a:prstGeom>
+          <a:noFill/>
+        </p:spPr>
+        <p:txBody>
+          <a:bodyPr wrap="square" anchor="t">
+            <a:spAutoFit/>
+          </a:bodyPr>
+          <a:lstStyle/>
+          <a:p>
+            <a:pPr algn="l">
+              <a:lnSpc>
+                <a:spcPct val="100000"/>
+              </a:lnSpc>
+              <a:spcAft>
+                <a:spcPts val="0"/>
+              </a:spcAft>
+            </a:pPr>
+            <a:r>
+              <a:rPr sz="3200" b="1" i="0">
+                <a:solidFill>
+                  <a:srgbClr val="7030A0"/>
+                </a:solidFill>
+                <a:latin typeface="Calibri"/>
+              </a:rPr>
+              <a:t>Q4 - How do you deal with the world?</a:t>
+            </a:r>
+          </a:p>
+        </p:txBody>
+      </p:sp>
+      <p:sp>
+        <p:nvSpPr>
+          <p:cNvPr id="3" name="Rectangle 2"/>
           <p:cNvSpPr/>
           <p:nvPr/>
         </p:nvSpPr>
         <p:spPr>
           <a:xfrm>
-            <a:off x="0" y="0"/>
-            <a:ext cx="201168" cy="6858000"/>
+            <a:off x="640080" y="1417320"/>
+            <a:ext cx="10972800" cy="2286000"/>
           </a:xfrm>
           <a:prstGeom prst="rect">
             <a:avLst/>
           </a:prstGeom>
           <a:solidFill>
-            <a:srgbClr val="502379"/>
+            <a:srgbClr val="F5F0FA"/>
           </a:solidFill>
-          <a:ln>
-            <a:noFill/>
+          <a:ln w="15240">
+            <a:solidFill>
+              <a:srgbClr val="7C3A9E"/>
+            </a:solidFill>
           </a:ln>
           <a:effectLst/>
         </p:spPr>
@@ -4834,14 +4566,14 @@
       </p:sp>
       <p:sp>
         <p:nvSpPr>
-          <p:cNvPr id="3" name="TextBox 2"/>
+          <p:cNvPr id="4" name="TextBox 3"/>
           <p:cNvSpPr txBox="1"/>
           <p:nvPr/>
         </p:nvSpPr>
         <p:spPr>
           <a:xfrm>
-            <a:off x="502920" y="274320"/>
-            <a:ext cx="11338560" cy="822960"/>
+            <a:off x="868680" y="1554480"/>
+            <a:ext cx="10515600" cy="2011680"/>
           </a:xfrm>
           <a:prstGeom prst="rect">
             <a:avLst/>
@@ -4849,69 +4581,55 @@
           <a:noFill/>
         </p:spPr>
         <p:txBody>
-          <a:bodyPr wrap="square" anchor="t">
+          <a:bodyPr wrap="square">
             <a:spAutoFit/>
           </a:bodyPr>
           <a:lstStyle/>
           <a:p>
-            <a:pPr algn="l">
+            <a:pPr>
               <a:lnSpc>
                 <a:spcPct val="100000"/>
               </a:lnSpc>
               <a:spcAft>
-                <a:spcPts val="600"/>
+                <a:spcPts val="400"/>
               </a:spcAft>
             </a:pPr>
             <a:r>
-              <a:rPr sz="2800" b="1" i="0">
-                <a:solidFill>
-                  <a:srgbClr val="502379"/>
+              <a:rPr sz="4000" b="1">
+                <a:solidFill>
+                  <a:srgbClr val="E74C3C"/>
                 </a:solidFill>
                 <a:latin typeface="Calibri"/>
               </a:rPr>
-              <a:t>Question 4 of 4</a:t>
-            </a:r>
-          </a:p>
-        </p:txBody>
-      </p:sp>
-      <p:sp>
-        <p:nvSpPr>
-          <p:cNvPr id="4" name="TextBox 3"/>
-          <p:cNvSpPr txBox="1"/>
-          <p:nvPr/>
-        </p:nvSpPr>
-        <p:spPr>
-          <a:xfrm>
-            <a:off x="502920" y="960120"/>
-            <a:ext cx="11338560" cy="457200"/>
-          </a:xfrm>
-          <a:prstGeom prst="rect">
-            <a:avLst/>
-          </a:prstGeom>
-          <a:noFill/>
-        </p:spPr>
-        <p:txBody>
-          <a:bodyPr wrap="square" anchor="t">
-            <a:spAutoFit/>
-          </a:bodyPr>
-          <a:lstStyle/>
-          <a:p>
-            <a:pPr algn="l">
+              <a:t>J</a:t>
+            </a:r>
+            <a:r>
+              <a:rPr sz="4000" b="1">
+                <a:solidFill>
+                  <a:srgbClr val="502379"/>
+                </a:solidFill>
+                <a:latin typeface="Calibri"/>
+              </a:rPr>
+              <a:t>UDGEMENT</a:t>
+            </a:r>
+          </a:p>
+          <a:p>
+            <a:pPr>
               <a:lnSpc>
-                <a:spcPct val="100000"/>
+                <a:spcPct val="110000"/>
               </a:lnSpc>
               <a:spcAft>
-                <a:spcPts val="600"/>
+                <a:spcPts val="0"/>
               </a:spcAft>
             </a:pPr>
             <a:r>
-              <a:rPr sz="1300" b="0" i="0">
-                <a:solidFill>
-                  <a:srgbClr val="666666"/>
+              <a:rPr sz="2000" b="0">
+                <a:solidFill>
+                  <a:srgbClr val="222222"/>
                 </a:solidFill>
                 <a:latin typeface="Calibri"/>
               </a:rPr>
-              <a:t>How do you deal with the world?</a:t>
+              <a:t>Judgement types are happiest after decisions are made. They set goals and work towards these, and prefer knowing exactly what is involved.</a:t>
             </a:r>
           </a:p>
         </p:txBody>
@@ -4924,7 +4642,7 @@
         </p:nvSpPr>
         <p:spPr>
           <a:xfrm>
-            <a:off x="640080" y="1554480"/>
+            <a:off x="640080" y="4023360"/>
             <a:ext cx="10972800" cy="2286000"/>
           </a:xfrm>
           <a:prstGeom prst="rect">
@@ -4970,8 +4688,8 @@
         </p:nvSpPr>
         <p:spPr>
           <a:xfrm>
-            <a:off x="868680" y="1737360"/>
-            <a:ext cx="10515600" cy="1920240"/>
+            <a:off x="868680" y="4160520"/>
+            <a:ext cx="10515600" cy="2011680"/>
           </a:xfrm>
           <a:prstGeom prst="rect">
             <a:avLst/>
@@ -4983,185 +4701,51 @@
             <a:spAutoFit/>
           </a:bodyPr>
           <a:lstStyle/>
+          <a:p>
+            <a:pPr>
+              <a:lnSpc>
+                <a:spcPct val="100000"/>
+              </a:lnSpc>
+              <a:spcAft>
+                <a:spcPts val="400"/>
+              </a:spcAft>
+            </a:pPr>
+            <a:r>
+              <a:rPr sz="4000" b="1">
+                <a:solidFill>
+                  <a:srgbClr val="E74C3C"/>
+                </a:solidFill>
+                <a:latin typeface="Calibri"/>
+              </a:rPr>
+              <a:t>P</a:t>
+            </a:r>
+            <a:r>
+              <a:rPr sz="4000" b="1">
+                <a:solidFill>
+                  <a:srgbClr val="502379"/>
+                </a:solidFill>
+                <a:latin typeface="Calibri"/>
+              </a:rPr>
+              <a:t>ERCEPTION</a:t>
+            </a:r>
+          </a:p>
           <a:p>
             <a:pPr>
               <a:lnSpc>
                 <a:spcPct val="110000"/>
               </a:lnSpc>
               <a:spcAft>
-                <a:spcPts val="200"/>
-              </a:spcAft>
-            </a:pPr>
-            <a:r>
-              <a:rPr sz="1800" b="1">
-                <a:solidFill>
-                  <a:srgbClr val="E74C3C"/>
-                </a:solidFill>
-                <a:latin typeface="Calibri"/>
-              </a:rPr>
-              <a:t>J</a:t>
-            </a:r>
-            <a:r>
-              <a:rPr sz="1800" b="1">
-                <a:solidFill>
-                  <a:srgbClr val="502379"/>
-                </a:solidFill>
-                <a:latin typeface="Calibri"/>
-              </a:rPr>
-              <a:t>UDGEMENT</a:t>
-            </a:r>
-          </a:p>
-          <a:p>
-            <a:pPr>
-              <a:lnSpc>
-                <a:spcPct val="115000"/>
-              </a:lnSpc>
-              <a:spcAft>
                 <a:spcPts val="0"/>
               </a:spcAft>
             </a:pPr>
             <a:r>
-              <a:rPr sz="1500" b="0">
-                <a:solidFill>
-                  <a:srgbClr val="E74C3C"/>
+              <a:rPr sz="2000" b="0">
+                <a:solidFill>
+                  <a:srgbClr val="222222"/>
                 </a:solidFill>
                 <a:latin typeface="Calibri"/>
               </a:rPr>
-              <a:t>J</a:t>
-            </a:r>
-            <a:r>
-              <a:rPr sz="1500" b="0">
-                <a:solidFill>
-                  <a:srgbClr val="222222"/>
-                </a:solidFill>
-                <a:latin typeface="Calibri"/>
-              </a:rPr>
-              <a:t>udgement types are happiest after decisions are made. They set goals and work towards these, and prefer knowing exactly what is involved.</a:t>
-            </a:r>
-          </a:p>
-        </p:txBody>
-      </p:sp>
-      <p:sp>
-        <p:nvSpPr>
-          <p:cNvPr id="7" name="Rectangle 6"/>
-          <p:cNvSpPr/>
-          <p:nvPr/>
-        </p:nvSpPr>
-        <p:spPr>
-          <a:xfrm>
-            <a:off x="640080" y="4023360"/>
-            <a:ext cx="10972800" cy="2286000"/>
-          </a:xfrm>
-          <a:prstGeom prst="rect">
-            <a:avLst/>
-          </a:prstGeom>
-          <a:solidFill>
-            <a:srgbClr val="F5F0FA"/>
-          </a:solidFill>
-          <a:ln w="15240">
-            <a:solidFill>
-              <a:srgbClr val="7C3A9E"/>
-            </a:solidFill>
-          </a:ln>
-          <a:effectLst/>
-        </p:spPr>
-        <p:style>
-          <a:lnRef idx="1">
-            <a:schemeClr val="accent1"/>
-          </a:lnRef>
-          <a:fillRef idx="3">
-            <a:schemeClr val="accent1"/>
-          </a:fillRef>
-          <a:effectRef idx="2">
-            <a:schemeClr val="accent1"/>
-          </a:effectRef>
-          <a:fontRef idx="minor">
-            <a:schemeClr val="lt1"/>
-          </a:fontRef>
-        </p:style>
-        <p:txBody>
-          <a:bodyPr rtlCol="0" anchor="ctr"/>
-          <a:lstStyle/>
-          <a:p>
-            <a:pPr algn="ctr"/>
-          </a:p>
-        </p:txBody>
-      </p:sp>
-      <p:sp>
-        <p:nvSpPr>
-          <p:cNvPr id="8" name="TextBox 7"/>
-          <p:cNvSpPr txBox="1"/>
-          <p:nvPr/>
-        </p:nvSpPr>
-        <p:spPr>
-          <a:xfrm>
-            <a:off x="868680" y="4206240"/>
-            <a:ext cx="10515600" cy="1920240"/>
-          </a:xfrm>
-          <a:prstGeom prst="rect">
-            <a:avLst/>
-          </a:prstGeom>
-          <a:noFill/>
-        </p:spPr>
-        <p:txBody>
-          <a:bodyPr wrap="square">
-            <a:spAutoFit/>
-          </a:bodyPr>
-          <a:lstStyle/>
-          <a:p>
-            <a:pPr>
-              <a:lnSpc>
-                <a:spcPct val="110000"/>
-              </a:lnSpc>
-              <a:spcAft>
-                <a:spcPts val="200"/>
-              </a:spcAft>
-            </a:pPr>
-            <a:r>
-              <a:rPr sz="1800" b="1">
-                <a:solidFill>
-                  <a:srgbClr val="E74C3C"/>
-                </a:solidFill>
-                <a:latin typeface="Calibri"/>
-              </a:rPr>
-              <a:t>P</a:t>
-            </a:r>
-            <a:r>
-              <a:rPr sz="1800" b="1">
-                <a:solidFill>
-                  <a:srgbClr val="502379"/>
-                </a:solidFill>
-                <a:latin typeface="Calibri"/>
-              </a:rPr>
-              <a:t>ERCEPTION</a:t>
-            </a:r>
-          </a:p>
-          <a:p>
-            <a:pPr>
-              <a:lnSpc>
-                <a:spcPct val="115000"/>
-              </a:lnSpc>
-              <a:spcAft>
-                <a:spcPts val="0"/>
-              </a:spcAft>
-            </a:pPr>
-            <a:r>
-              <a:rPr sz="1500" b="0">
-                <a:solidFill>
-                  <a:srgbClr val="E74C3C"/>
-                </a:solidFill>
-                <a:latin typeface="Calibri"/>
-              </a:rPr>
-              <a:t>P</a:t>
-            </a:r>
-            <a:r>
-              <a:rPr sz="1500" b="0">
-                <a:solidFill>
-                  <a:srgbClr val="222222"/>
-                </a:solidFill>
-                <a:latin typeface="Calibri"/>
-              </a:rPr>
-              <a:t>erception types prefer to leave options open. They enjoy adapting to new situations and cope well with ambiguity.</a:t>
+              <a:t>Perception types prefer to leave options open. They enjoy adapting to new situations and cope well with ambiguity.</a:t>
             </a:r>
           </a:p>
         </p:txBody>

</xml_diff>

<commit_message>
Add closing slide and cheatsheet
</commit_message>
<xml_diff>
--- a/Effective_Teamwork_2_survey.pptx
+++ b/Effective_Teamwork_2_survey.pptx
@@ -12,6 +12,7 @@
     <p:sldId id="260" r:id="rId11"/>
     <p:sldId id="261" r:id="rId12"/>
     <p:sldId id="262" r:id="rId13"/>
+    <p:sldId id="263" r:id="rId14"/>
   </p:sldIdLst>
   <p:sldSz cx="12191695" cy="6858000" type="screen4x3"/>
   <p:notesSz cx="6858000" cy="9144000"/>
@@ -5339,6 +5340,221 @@
                 <a:latin typeface="Calibri"/>
               </a:rPr>
               <a:t>We will look up each result together.</a:t>
+            </a:r>
+          </a:p>
+        </p:txBody>
+      </p:sp>
+    </p:spTree>
+  </p:cSld>
+  <p:clrMapOvr>
+    <a:masterClrMapping/>
+  </p:clrMapOvr>
+</p:sld>
+</file>
+
+<file path=ppt/slides/slide8.xml><?xml version="1.0" encoding="utf-8"?>
+<p:sld xmlns:a="http://schemas.openxmlformats.org/drawingml/2006/main" xmlns:p="http://schemas.openxmlformats.org/presentationml/2006/main" xmlns:r="http://schemas.openxmlformats.org/officeDocument/2006/relationships">
+  <p:cSld>
+    <p:bg>
+      <p:bgPr>
+        <a:solidFill>
+          <a:srgbClr val="30124E"/>
+        </a:solidFill>
+        <a:effectLst/>
+      </p:bgPr>
+    </p:bg>
+    <p:spTree>
+      <p:nvGrpSpPr>
+        <p:cNvPr id="1" name=""/>
+        <p:cNvGrpSpPr/>
+        <p:nvPr/>
+      </p:nvGrpSpPr>
+      <p:grpSpPr/>
+      <p:sp>
+        <p:nvSpPr>
+          <p:cNvPr id="2" name="Rectangle 1"/>
+          <p:cNvSpPr/>
+          <p:nvPr/>
+        </p:nvSpPr>
+        <p:spPr>
+          <a:xfrm>
+            <a:off x="0" y="2377440"/>
+            <a:ext cx="12191695" cy="54864"/>
+          </a:xfrm>
+          <a:prstGeom prst="rect">
+            <a:avLst/>
+          </a:prstGeom>
+          <a:solidFill>
+            <a:srgbClr val="7C3A9E"/>
+          </a:solidFill>
+          <a:ln>
+            <a:noFill/>
+          </a:ln>
+          <a:effectLst/>
+        </p:spPr>
+        <p:style>
+          <a:lnRef idx="1">
+            <a:schemeClr val="accent1"/>
+          </a:lnRef>
+          <a:fillRef idx="3">
+            <a:schemeClr val="accent1"/>
+          </a:fillRef>
+          <a:effectRef idx="2">
+            <a:schemeClr val="accent1"/>
+          </a:effectRef>
+          <a:fontRef idx="minor">
+            <a:schemeClr val="lt1"/>
+          </a:fontRef>
+        </p:style>
+        <p:txBody>
+          <a:bodyPr rtlCol="0" anchor="ctr"/>
+          <a:lstStyle/>
+          <a:p>
+            <a:pPr algn="ctr"/>
+          </a:p>
+        </p:txBody>
+      </p:sp>
+      <p:sp>
+        <p:nvSpPr>
+          <p:cNvPr id="3" name="TextBox 2"/>
+          <p:cNvSpPr txBox="1"/>
+          <p:nvPr/>
+        </p:nvSpPr>
+        <p:spPr>
+          <a:xfrm>
+            <a:off x="914400" y="1737360"/>
+            <a:ext cx="10332720" cy="1463040"/>
+          </a:xfrm>
+          <a:prstGeom prst="rect">
+            <a:avLst/>
+          </a:prstGeom>
+          <a:noFill/>
+        </p:spPr>
+        <p:txBody>
+          <a:bodyPr wrap="square" anchor="t">
+            <a:spAutoFit/>
+          </a:bodyPr>
+          <a:lstStyle/>
+          <a:p>
+            <a:pPr algn="l">
+              <a:lnSpc>
+                <a:spcPct val="125000"/>
+              </a:lnSpc>
+              <a:spcAft>
+                <a:spcPts val="600"/>
+              </a:spcAft>
+            </a:pPr>
+            <a:r>
+              <a:rPr sz="2600" b="0" i="0">
+                <a:solidFill>
+                  <a:srgbClr val="D8C8E8"/>
+                </a:solidFill>
+                <a:latin typeface="Calibri"/>
+              </a:rPr>
+              <a:t>I hope this test helps you understand</a:t>
+            </a:r>
+          </a:p>
+          <a:p>
+            <a:pPr algn="l">
+              <a:lnSpc>
+                <a:spcPct val="125000"/>
+              </a:lnSpc>
+              <a:spcAft>
+                <a:spcPts val="600"/>
+              </a:spcAft>
+            </a:pPr>
+            <a:r>
+              <a:rPr sz="2600" b="0" i="0">
+                <a:solidFill>
+                  <a:srgbClr val="D8C8E8"/>
+                </a:solidFill>
+                <a:latin typeface="Calibri"/>
+              </a:rPr>
+              <a:t>the role that best fits you in a team.</a:t>
+            </a:r>
+          </a:p>
+        </p:txBody>
+      </p:sp>
+      <p:sp>
+        <p:nvSpPr>
+          <p:cNvPr id="4" name="TextBox 3"/>
+          <p:cNvSpPr txBox="1"/>
+          <p:nvPr/>
+        </p:nvSpPr>
+        <p:spPr>
+          <a:xfrm>
+            <a:off x="914400" y="3657600"/>
+            <a:ext cx="10332720" cy="731520"/>
+          </a:xfrm>
+          <a:prstGeom prst="rect">
+            <a:avLst/>
+          </a:prstGeom>
+          <a:noFill/>
+        </p:spPr>
+        <p:txBody>
+          <a:bodyPr wrap="square" anchor="t">
+            <a:spAutoFit/>
+          </a:bodyPr>
+          <a:lstStyle/>
+          <a:p>
+            <a:pPr algn="l">
+              <a:lnSpc>
+                <a:spcPct val="100000"/>
+              </a:lnSpc>
+              <a:spcAft>
+                <a:spcPts val="600"/>
+              </a:spcAft>
+            </a:pPr>
+            <a:r>
+              <a:rPr sz="2000" b="0" i="0">
+                <a:solidFill>
+                  <a:srgbClr val="B9A6D0"/>
+                </a:solidFill>
+                <a:latin typeface="Calibri"/>
+              </a:rPr>
+              <a:t>I hope this result can be helpful to you.</a:t>
+            </a:r>
+          </a:p>
+        </p:txBody>
+      </p:sp>
+      <p:sp>
+        <p:nvSpPr>
+          <p:cNvPr id="5" name="TextBox 4"/>
+          <p:cNvSpPr txBox="1"/>
+          <p:nvPr/>
+        </p:nvSpPr>
+        <p:spPr>
+          <a:xfrm>
+            <a:off x="914400" y="5029200"/>
+            <a:ext cx="10332720" cy="822960"/>
+          </a:xfrm>
+          <a:prstGeom prst="rect">
+            <a:avLst/>
+          </a:prstGeom>
+          <a:noFill/>
+        </p:spPr>
+        <p:txBody>
+          <a:bodyPr wrap="square" anchor="t">
+            <a:spAutoFit/>
+          </a:bodyPr>
+          <a:lstStyle/>
+          <a:p>
+            <a:pPr algn="l">
+              <a:lnSpc>
+                <a:spcPct val="100000"/>
+              </a:lnSpc>
+              <a:spcAft>
+                <a:spcPts val="600"/>
+              </a:spcAft>
+            </a:pPr>
+            <a:r>
+              <a:rPr sz="3200" b="1" i="0">
+                <a:solidFill>
+                  <a:srgbClr val="FFFFFF"/>
+                </a:solidFill>
+                <a:latin typeface="Calibri"/>
+              </a:rPr>
+              <a:t>Thanks for listening</a:t>
             </a:r>
           </a:p>
         </p:txBody>

</xml_diff>